<commit_message>
BUILD6 production: finalize rebrand and 16-week assignments repair
</commit_message>
<xml_diff>
--- a/protected-resources/ambassador/week-09/Future-Ready-Week-09-Slides.pptx
+++ b/protected-resources/ambassador/week-09/Future-Ready-Week-09-Slides.pptx
@@ -11,12 +11,6 @@
     <p:sldId id="259" r:id="rId10"/>
     <p:sldId id="260" r:id="rId11"/>
     <p:sldId id="261" r:id="rId12"/>
-    <p:sldId id="262" r:id="rId13"/>
-    <p:sldId id="263" r:id="rId14"/>
-    <p:sldId id="264" r:id="rId15"/>
-    <p:sldId id="265" r:id="rId16"/>
-    <p:sldId id="266" r:id="rId17"/>
-    <p:sldId id="267" r:id="rId18"/>
   </p:sldIdLst>
   <p:sldSz cx="12191695" cy="6858000" type="screen4x3"/>
   <p:notesSz cx="6858000" cy="9144000"/>
@@ -3095,7 +3089,7 @@
     <p:bg>
       <p:bgPr>
         <a:solidFill>
-          <a:srgbClr val="062B3F"/>
+          <a:srgbClr val="F5F7FA"/>
         </a:solidFill>
         <a:effectLst/>
       </p:bgPr>
@@ -3109,20 +3103,20 @@
       <p:grpSpPr/>
       <p:sp>
         <p:nvSpPr>
-          <p:cNvPr id="2" name="Oval 1"/>
+          <p:cNvPr id="2" name="Rectangle 1"/>
           <p:cNvSpPr/>
           <p:nvPr/>
         </p:nvSpPr>
         <p:spPr>
           <a:xfrm>
-            <a:off x="685800" y="731520"/>
-            <a:ext cx="1051560" cy="1051560"/>
-          </a:xfrm>
-          <a:prstGeom prst="ellipse">
+            <a:off x="0" y="0"/>
+            <a:ext cx="12191695" cy="822960"/>
+          </a:xfrm>
+          <a:prstGeom prst="rect">
             <a:avLst/>
           </a:prstGeom>
           <a:solidFill>
-            <a:srgbClr val="F4C542"/>
+            <a:srgbClr val="0D1B3D"/>
           </a:solidFill>
           <a:ln>
             <a:noFill/>
@@ -3158,8 +3152,8 @@
         </p:nvSpPr>
         <p:spPr>
           <a:xfrm>
-            <a:off x="960120" y="1828800"/>
-            <a:ext cx="10241280" cy="1828800"/>
+            <a:off x="411480" y="146304"/>
+            <a:ext cx="11155680" cy="502920"/>
           </a:xfrm>
           <a:prstGeom prst="rect">
             <a:avLst/>
@@ -3172,39 +3166,13 @@
           </a:bodyPr>
           <a:lstStyle/>
           <a:p>
-            <a:pPr>
-              <a:defRPr sz="2400" b="1">
-                <a:solidFill>
-                  <a:srgbClr val="00A6A6"/>
-                </a:solidFill>
-              </a:defRPr>
-            </a:pPr>
-            <a:r>
-              <a:t>WEEK 9</a:t>
-            </a:r>
-          </a:p>
-          <a:p>
-            <a:pPr>
-              <a:defRPr sz="3800" b="1">
-                <a:solidFill>
-                  <a:srgbClr val="FFFFFF"/>
-                </a:solidFill>
-              </a:defRPr>
-            </a:pPr>
-            <a:r>
-              <a:t>Jennifer Miller — Resume Story Bank</a:t>
-            </a:r>
-          </a:p>
-          <a:p>
-            <a:pPr>
-              <a:defRPr sz="2000">
-                <a:solidFill>
-                  <a:srgbClr val="F4C542"/>
-                </a:solidFill>
-              </a:defRPr>
-            </a:pPr>
-            <a:r>
-              <a:t>October 15, 2026 · CONNECT™</a:t>
+            <a:r>
+              <a:rPr sz="1200" b="1">
+                <a:solidFill>
+                  <a:srgbClr val="F2B705"/>
+                </a:solidFill>
+              </a:rPr>
+              <a:t>BUILD6™ · WEEK 9</a:t>
             </a:r>
           </a:p>
         </p:txBody>
@@ -3217,8 +3185,8 @@
         </p:nvSpPr>
         <p:spPr>
           <a:xfrm>
-            <a:off x="960120" y="5212080"/>
-            <a:ext cx="10058400" cy="640080"/>
+            <a:off x="502920" y="1143000"/>
+            <a:ext cx="11064240" cy="1097280"/>
           </a:xfrm>
           <a:prstGeom prst="rect">
             <a:avLst/>
@@ -3231,35 +3199,126 @@
           </a:bodyPr>
           <a:lstStyle/>
           <a:p>
-            <a:pPr>
-              <a:defRPr sz="1800" b="1">
-                <a:solidFill>
-                  <a:srgbClr val="FFFFFF"/>
-                </a:solidFill>
-              </a:defRPr>
-            </a:pPr>
-            <a:r>
-              <a:t>BUILD6™ · BUILD WHAT’S NEXT.</a:t>
-            </a:r>
-          </a:p>
-        </p:txBody>
-      </p:sp>
-      <p:sp>
-        <p:nvSpPr>
-          <p:cNvPr id="5" name="Rectangle 4"/>
+            <a:r>
+              <a:rPr sz="3000" b="1">
+                <a:solidFill>
+                  <a:srgbClr val="0D1B3D"/>
+                </a:solidFill>
+              </a:rPr>
+              <a:t>AI at Work</a:t>
+            </a:r>
+          </a:p>
+        </p:txBody>
+      </p:sp>
+      <p:sp>
+        <p:nvSpPr>
+          <p:cNvPr id="5" name="TextBox 4"/>
+          <p:cNvSpPr txBox="1"/>
+          <p:nvPr/>
+        </p:nvSpPr>
+        <p:spPr>
+          <a:xfrm>
+            <a:off x="530352" y="2148840"/>
+            <a:ext cx="10789920" cy="731520"/>
+          </a:xfrm>
+          <a:prstGeom prst="rect">
+            <a:avLst/>
+          </a:prstGeom>
+          <a:noFill/>
+        </p:spPr>
+        <p:txBody>
+          <a:bodyPr wrap="none">
+            <a:spAutoFit/>
+          </a:bodyPr>
+          <a:lstStyle/>
+          <a:p>
+            <a:r>
+              <a:rPr sz="1600">
+                <a:solidFill>
+                  <a:srgbClr val="3C4655"/>
+                </a:solidFill>
+              </a:rPr>
+              <a:t>Think Better. Work Smarter. Stay Human.</a:t>
+            </a:r>
+          </a:p>
+        </p:txBody>
+      </p:sp>
+      <p:sp>
+        <p:nvSpPr>
+          <p:cNvPr id="6" name="TextBox 5"/>
+          <p:cNvSpPr txBox="1"/>
+          <p:nvPr/>
+        </p:nvSpPr>
+        <p:spPr>
+          <a:xfrm>
+            <a:off x="640080" y="3749039"/>
+            <a:ext cx="10972800" cy="1097280"/>
+          </a:xfrm>
+          <a:prstGeom prst="rect">
+            <a:avLst/>
+          </a:prstGeom>
+          <a:noFill/>
+        </p:spPr>
+        <p:txBody>
+          <a:bodyPr wrap="none">
+            <a:spAutoFit/>
+          </a:bodyPr>
+          <a:lstStyle/>
+          <a:p>
+            <a:pPr algn="ctr"/>
+            <a:r>
+              <a:rPr sz="2200" b="1">
+                <a:solidFill>
+                  <a:srgbClr val="4B2265"/>
+                </a:solidFill>
+              </a:rPr>
+              <a:t>How do I use AI without giving up my own thinking?</a:t>
+            </a:r>
+          </a:p>
+        </p:txBody>
+      </p:sp>
+    </p:spTree>
+  </p:cSld>
+  <p:clrMapOvr>
+    <a:masterClrMapping/>
+  </p:clrMapOvr>
+</p:sld>
+</file>
+
+<file path=ppt/slides/slide2.xml><?xml version="1.0" encoding="utf-8"?>
+<p:sld xmlns:a="http://schemas.openxmlformats.org/drawingml/2006/main" xmlns:p="http://schemas.openxmlformats.org/presentationml/2006/main" xmlns:r="http://schemas.openxmlformats.org/officeDocument/2006/relationships">
+  <p:cSld>
+    <p:bg>
+      <p:bgPr>
+        <a:solidFill>
+          <a:srgbClr val="F5F7FA"/>
+        </a:solidFill>
+        <a:effectLst/>
+      </p:bgPr>
+    </p:bg>
+    <p:spTree>
+      <p:nvGrpSpPr>
+        <p:cNvPr id="1" name=""/>
+        <p:cNvGrpSpPr/>
+        <p:nvPr/>
+      </p:nvGrpSpPr>
+      <p:grpSpPr/>
+      <p:sp>
+        <p:nvSpPr>
+          <p:cNvPr id="2" name="Rectangle 1"/>
           <p:cNvSpPr/>
           <p:nvPr/>
         </p:nvSpPr>
         <p:spPr>
           <a:xfrm>
-            <a:off x="0" y="6446520"/>
-            <a:ext cx="12191695" cy="411480"/>
+            <a:off x="0" y="0"/>
+            <a:ext cx="12191695" cy="822960"/>
           </a:xfrm>
           <a:prstGeom prst="rect">
             <a:avLst/>
           </a:prstGeom>
           <a:solidFill>
-            <a:srgbClr val="062B3F"/>
+            <a:srgbClr val="0D1B3D"/>
           </a:solidFill>
           <a:ln>
             <a:noFill/>
@@ -3289,14 +3348,14 @@
       </p:sp>
       <p:sp>
         <p:nvSpPr>
-          <p:cNvPr id="6" name="TextBox 5"/>
+          <p:cNvPr id="3" name="TextBox 2"/>
           <p:cNvSpPr txBox="1"/>
           <p:nvPr/>
         </p:nvSpPr>
         <p:spPr>
           <a:xfrm>
-            <a:off x="457200" y="6510528"/>
-            <a:ext cx="11247120" cy="182880"/>
+            <a:off x="411480" y="146304"/>
+            <a:ext cx="11155680" cy="502920"/>
           </a:xfrm>
           <a:prstGeom prst="rect">
             <a:avLst/>
@@ -3309,15 +3368,174 @@
           </a:bodyPr>
           <a:lstStyle/>
           <a:p>
-            <a:pPr algn="ctr">
-              <a:defRPr sz="900">
-                <a:solidFill>
-                  <a:srgbClr val="FFFFFF"/>
+            <a:r>
+              <a:rPr sz="1200" b="1">
+                <a:solidFill>
+                  <a:srgbClr val="F2B705"/>
+                </a:solidFill>
+              </a:rPr>
+              <a:t>WEEK 9</a:t>
+            </a:r>
+          </a:p>
+        </p:txBody>
+      </p:sp>
+      <p:sp>
+        <p:nvSpPr>
+          <p:cNvPr id="4" name="TextBox 3"/>
+          <p:cNvSpPr txBox="1"/>
+          <p:nvPr/>
+        </p:nvSpPr>
+        <p:spPr>
+          <a:xfrm>
+            <a:off x="502920" y="1143000"/>
+            <a:ext cx="11064240" cy="1097280"/>
+          </a:xfrm>
+          <a:prstGeom prst="rect">
+            <a:avLst/>
+          </a:prstGeom>
+          <a:noFill/>
+        </p:spPr>
+        <p:txBody>
+          <a:bodyPr wrap="none">
+            <a:spAutoFit/>
+          </a:bodyPr>
+          <a:lstStyle/>
+          <a:p>
+            <a:r>
+              <a:rPr sz="3000" b="1">
+                <a:solidFill>
+                  <a:srgbClr val="0D1B3D"/>
+                </a:solidFill>
+              </a:rPr>
+              <a:t>This Week Builds</a:t>
+            </a:r>
+          </a:p>
+        </p:txBody>
+      </p:sp>
+      <p:sp>
+        <p:nvSpPr>
+          <p:cNvPr id="5" name="TextBox 4"/>
+          <p:cNvSpPr txBox="1"/>
+          <p:nvPr/>
+        </p:nvSpPr>
+        <p:spPr>
+          <a:xfrm>
+            <a:off x="731520" y="2011680"/>
+            <a:ext cx="10789920" cy="4297680"/>
+          </a:xfrm>
+          <a:prstGeom prst="rect">
+            <a:avLst/>
+          </a:prstGeom>
+          <a:noFill/>
+        </p:spPr>
+        <p:txBody>
+          <a:bodyPr wrap="square">
+            <a:spAutoFit/>
+          </a:bodyPr>
+          <a:lstStyle/>
+          <a:p>
+            <a:pPr>
+              <a:spcAft>
+                <a:spcPts val="1000"/>
+              </a:spcAft>
+              <a:defRPr sz="2000">
+                <a:solidFill>
+                  <a:srgbClr val="192332"/>
                 </a:solidFill>
               </a:defRPr>
             </a:pPr>
             <a:r>
-              <a:t>BUILD6™ · WEEK 9 · © 2026 LINK Lake Norman, LLC · All Rights Reserved</a:t>
+              <a:t>Critical thinking</a:t>
+            </a:r>
+          </a:p>
+          <a:p>
+            <a:pPr>
+              <a:spcAft>
+                <a:spcPts val="1000"/>
+              </a:spcAft>
+              <a:defRPr sz="2000">
+                <a:solidFill>
+                  <a:srgbClr val="192332"/>
+                </a:solidFill>
+              </a:defRPr>
+            </a:pPr>
+            <a:r>
+              <a:t>Prompt design</a:t>
+            </a:r>
+          </a:p>
+          <a:p>
+            <a:pPr>
+              <a:spcAft>
+                <a:spcPts val="1000"/>
+              </a:spcAft>
+              <a:defRPr sz="2000">
+                <a:solidFill>
+                  <a:srgbClr val="192332"/>
+                </a:solidFill>
+              </a:defRPr>
+            </a:pPr>
+            <a:r>
+              <a:t>Verification</a:t>
+            </a:r>
+          </a:p>
+          <a:p>
+            <a:pPr>
+              <a:spcAft>
+                <a:spcPts val="1000"/>
+              </a:spcAft>
+              <a:defRPr sz="2000">
+                <a:solidFill>
+                  <a:srgbClr val="192332"/>
+                </a:solidFill>
+              </a:defRPr>
+            </a:pPr>
+            <a:r>
+              <a:t>Privacy &amp; confidentiality</a:t>
+            </a:r>
+          </a:p>
+          <a:p>
+            <a:pPr>
+              <a:spcAft>
+                <a:spcPts val="1000"/>
+              </a:spcAft>
+              <a:defRPr sz="2000">
+                <a:solidFill>
+                  <a:srgbClr val="192332"/>
+                </a:solidFill>
+              </a:defRPr>
+            </a:pPr>
+            <a:r>
+              <a:t>Bias / hallucination awareness</a:t>
+            </a:r>
+          </a:p>
+          <a:p>
+            <a:pPr>
+              <a:spcAft>
+                <a:spcPts val="1000"/>
+              </a:spcAft>
+              <a:defRPr sz="2000">
+                <a:solidFill>
+                  <a:srgbClr val="192332"/>
+                </a:solidFill>
+              </a:defRPr>
+            </a:pPr>
+            <a:r>
+              <a:t>Professional judgment</a:t>
+            </a:r>
+          </a:p>
+          <a:p>
+            <a:pPr>
+              <a:spcAft>
+                <a:spcPts val="1000"/>
+              </a:spcAft>
+              <a:defRPr sz="2000">
+                <a:solidFill>
+                  <a:srgbClr val="192332"/>
+                </a:solidFill>
+              </a:defRPr>
+            </a:pPr>
+            <a:r>
+              <a:t>Human ownership</a:t>
             </a:r>
           </a:p>
         </p:txBody>
@@ -3330,13 +3548,13 @@
 </p:sld>
 </file>
 
-<file path=ppt/slides/slide10.xml><?xml version="1.0" encoding="utf-8"?>
+<file path=ppt/slides/slide3.xml><?xml version="1.0" encoding="utf-8"?>
 <p:sld xmlns:a="http://schemas.openxmlformats.org/drawingml/2006/main" xmlns:p="http://schemas.openxmlformats.org/presentationml/2006/main" xmlns:r="http://schemas.openxmlformats.org/officeDocument/2006/relationships">
   <p:cSld>
     <p:bg>
       <p:bgPr>
         <a:solidFill>
-          <a:srgbClr val="F5F9FA"/>
+          <a:srgbClr val="F5F7FA"/>
         </a:solidFill>
         <a:effectLst/>
       </p:bgPr>
@@ -3357,13 +3575,13 @@
         <p:spPr>
           <a:xfrm>
             <a:off x="0" y="0"/>
-            <a:ext cx="164592" cy="6858000"/>
+            <a:ext cx="12191695" cy="822960"/>
           </a:xfrm>
           <a:prstGeom prst="rect">
             <a:avLst/>
           </a:prstGeom>
           <a:solidFill>
-            <a:srgbClr val="00A6A6"/>
+            <a:srgbClr val="0D1B3D"/>
           </a:solidFill>
           <a:ln>
             <a:noFill/>
@@ -3399,8 +3617,8 @@
         </p:nvSpPr>
         <p:spPr>
           <a:xfrm>
-            <a:off x="594360" y="411480"/>
-            <a:ext cx="10972800" cy="640080"/>
+            <a:off x="411480" y="146304"/>
+            <a:ext cx="11155680" cy="502920"/>
           </a:xfrm>
           <a:prstGeom prst="rect">
             <a:avLst/>
@@ -3413,16 +3631,13 @@
           </a:bodyPr>
           <a:lstStyle/>
           <a:p>
-            <a:pPr>
-              <a:defRPr sz="2900" b="1">
-                <a:solidFill>
-                  <a:srgbClr val="062B3F"/>
-                </a:solidFill>
-                <a:latin typeface="Aptos Display"/>
-              </a:defRPr>
-            </a:pPr>
-            <a:r>
-              <a:t>Portfolio Evidence</a:t>
+            <a:r>
+              <a:rPr sz="1200" b="1">
+                <a:solidFill>
+                  <a:srgbClr val="F2B705"/>
+                </a:solidFill>
+              </a:rPr>
+              <a:t>TUESDAY</a:t>
             </a:r>
           </a:p>
         </p:txBody>
@@ -3435,8 +3650,8 @@
         </p:nvSpPr>
         <p:spPr>
           <a:xfrm>
-            <a:off x="822960" y="1463040"/>
-            <a:ext cx="10561320" cy="4480560"/>
+            <a:off x="502920" y="1143000"/>
+            <a:ext cx="11064240" cy="1097280"/>
           </a:xfrm>
           <a:prstGeom prst="rect">
             <a:avLst/>
@@ -3444,6 +3659,72 @@
           <a:noFill/>
         </p:spPr>
         <p:txBody>
+          <a:bodyPr wrap="none">
+            <a:spAutoFit/>
+          </a:bodyPr>
+          <a:lstStyle/>
+          <a:p>
+            <a:r>
+              <a:rPr sz="3000" b="1">
+                <a:solidFill>
+                  <a:srgbClr val="0D1B3D"/>
+                </a:solidFill>
+              </a:rPr>
+              <a:t>Prompting + Workplace Problem-Solving Lab</a:t>
+            </a:r>
+          </a:p>
+        </p:txBody>
+      </p:sp>
+      <p:sp>
+        <p:nvSpPr>
+          <p:cNvPr id="5" name="TextBox 4"/>
+          <p:cNvSpPr txBox="1"/>
+          <p:nvPr/>
+        </p:nvSpPr>
+        <p:spPr>
+          <a:xfrm>
+            <a:off x="530352" y="2148840"/>
+            <a:ext cx="10789920" cy="731520"/>
+          </a:xfrm>
+          <a:prstGeom prst="rect">
+            <a:avLst/>
+          </a:prstGeom>
+          <a:noFill/>
+        </p:spPr>
+        <p:txBody>
+          <a:bodyPr wrap="none">
+            <a:spAutoFit/>
+          </a:bodyPr>
+          <a:lstStyle/>
+          <a:p>
+            <a:r>
+              <a:rPr sz="1600">
+                <a:solidFill>
+                  <a:srgbClr val="3C4655"/>
+                </a:solidFill>
+              </a:rPr>
+              <a:t>Practice ROLE + CONTEXT + GOAL + AUDIENCE + CONSTRAINTS + FORMAT. Improve weak prompts and decide what the human must still own.</a:t>
+            </a:r>
+          </a:p>
+        </p:txBody>
+      </p:sp>
+      <p:sp>
+        <p:nvSpPr>
+          <p:cNvPr id="6" name="TextBox 5"/>
+          <p:cNvSpPr txBox="1"/>
+          <p:nvPr/>
+        </p:nvSpPr>
+        <p:spPr>
+          <a:xfrm>
+            <a:off x="731520" y="2971800"/>
+            <a:ext cx="10789920" cy="3017520"/>
+          </a:xfrm>
+          <a:prstGeom prst="rect">
+            <a:avLst/>
+          </a:prstGeom>
+          <a:noFill/>
+        </p:spPr>
+        <p:txBody>
           <a:bodyPr wrap="square">
             <a:spAutoFit/>
           </a:bodyPr>
@@ -3451,85 +3732,92 @@
           <a:p>
             <a:pPr>
               <a:spcAft>
-                <a:spcPts val="1400"/>
+                <a:spcPts val="800"/>
               </a:spcAft>
-              <a:defRPr sz="2100">
-                <a:solidFill>
-                  <a:srgbClr val="1B262C"/>
-                </a:solidFill>
-                <a:latin typeface="Aptos"/>
+              <a:defRPr sz="1700">
+                <a:solidFill>
+                  <a:srgbClr val="192332"/>
+                </a:solidFill>
               </a:defRPr>
             </a:pPr>
             <a:r>
-              <a:t>What artifact should I save?</a:t>
+              <a:t>Rewrite: “Help me get a job.”</a:t>
             </a:r>
           </a:p>
           <a:p>
             <a:pPr>
               <a:spcAft>
-                <a:spcPts val="1400"/>
+                <a:spcPts val="800"/>
               </a:spcAft>
-              <a:defRPr sz="2100">
-                <a:solidFill>
-                  <a:srgbClr val="1B262C"/>
-                </a:solidFill>
-                <a:latin typeface="Aptos"/>
+              <a:defRPr sz="1700">
+                <a:solidFill>
+                  <a:srgbClr val="192332"/>
+                </a:solidFill>
               </a:defRPr>
             </a:pPr>
             <a:r>
-              <a:t>What does this evidence show about me?</a:t>
+              <a:t>What context or constraints did you add?</a:t>
             </a:r>
           </a:p>
           <a:p>
             <a:pPr>
               <a:spcAft>
-                <a:spcPts val="1400"/>
+                <a:spcPts val="800"/>
               </a:spcAft>
-              <a:defRPr sz="2100">
-                <a:solidFill>
-                  <a:srgbClr val="1B262C"/>
-                </a:solidFill>
-                <a:latin typeface="Aptos"/>
+              <a:defRPr sz="1700">
+                <a:solidFill>
+                  <a:srgbClr val="192332"/>
+                </a:solidFill>
               </a:defRPr>
             </a:pPr>
             <a:r>
-              <a:t>Which BUILD6 skill does it demonstrate?</a:t>
-            </a:r>
-          </a:p>
-          <a:p>
-            <a:pPr>
-              <a:spcAft>
-                <a:spcPts val="1400"/>
-              </a:spcAft>
-              <a:defRPr sz="2100">
-                <a:solidFill>
-                  <a:srgbClr val="1B262C"/>
-                </a:solidFill>
-                <a:latin typeface="Aptos"/>
-              </a:defRPr>
-            </a:pPr>
-            <a:r>
-              <a:t>Would someone outside this class understand why it matters?</a:t>
-            </a:r>
-          </a:p>
-        </p:txBody>
-      </p:sp>
-      <p:sp>
-        <p:nvSpPr>
-          <p:cNvPr id="5" name="Rectangle 4"/>
+              <a:t>What should the human still decide?</a:t>
+            </a:r>
+          </a:p>
+        </p:txBody>
+      </p:sp>
+    </p:spTree>
+  </p:cSld>
+  <p:clrMapOvr>
+    <a:masterClrMapping/>
+  </p:clrMapOvr>
+</p:sld>
+</file>
+
+<file path=ppt/slides/slide4.xml><?xml version="1.0" encoding="utf-8"?>
+<p:sld xmlns:a="http://schemas.openxmlformats.org/drawingml/2006/main" xmlns:p="http://schemas.openxmlformats.org/presentationml/2006/main" xmlns:r="http://schemas.openxmlformats.org/officeDocument/2006/relationships">
+  <p:cSld>
+    <p:bg>
+      <p:bgPr>
+        <a:solidFill>
+          <a:srgbClr val="F5F7FA"/>
+        </a:solidFill>
+        <a:effectLst/>
+      </p:bgPr>
+    </p:bg>
+    <p:spTree>
+      <p:nvGrpSpPr>
+        <p:cNvPr id="1" name=""/>
+        <p:cNvGrpSpPr/>
+        <p:nvPr/>
+      </p:nvGrpSpPr>
+      <p:grpSpPr/>
+      <p:sp>
+        <p:nvSpPr>
+          <p:cNvPr id="2" name="Rectangle 1"/>
           <p:cNvSpPr/>
           <p:nvPr/>
         </p:nvSpPr>
         <p:spPr>
           <a:xfrm>
-            <a:off x="0" y="6446520"/>
-            <a:ext cx="12191695" cy="411480"/>
+            <a:off x="0" y="0"/>
+            <a:ext cx="12191695" cy="822960"/>
           </a:xfrm>
           <a:prstGeom prst="rect">
             <a:avLst/>
           </a:prstGeom>
           <a:solidFill>
-            <a:srgbClr val="062B3F"/>
+            <a:srgbClr val="0D1B3D"/>
           </a:solidFill>
           <a:ln>
             <a:noFill/>
@@ -3559,14 +3847,14 @@
       </p:sp>
       <p:sp>
         <p:nvSpPr>
-          <p:cNvPr id="6" name="TextBox 5"/>
+          <p:cNvPr id="3" name="TextBox 2"/>
           <p:cNvSpPr txBox="1"/>
           <p:nvPr/>
         </p:nvSpPr>
         <p:spPr>
           <a:xfrm>
-            <a:off x="457200" y="6510528"/>
-            <a:ext cx="11247120" cy="182880"/>
+            <a:off x="411480" y="146304"/>
+            <a:ext cx="11155680" cy="502920"/>
           </a:xfrm>
           <a:prstGeom prst="rect">
             <a:avLst/>
@@ -3579,15 +3867,162 @@
           </a:bodyPr>
           <a:lstStyle/>
           <a:p>
-            <a:pPr algn="ctr">
-              <a:defRPr sz="900">
-                <a:solidFill>
-                  <a:srgbClr val="FFFFFF"/>
+            <a:r>
+              <a:rPr sz="1200" b="1">
+                <a:solidFill>
+                  <a:srgbClr val="F2B705"/>
+                </a:solidFill>
+              </a:rPr>
+              <a:t>WEDNESDAY</a:t>
+            </a:r>
+          </a:p>
+        </p:txBody>
+      </p:sp>
+      <p:sp>
+        <p:nvSpPr>
+          <p:cNvPr id="4" name="TextBox 3"/>
+          <p:cNvSpPr txBox="1"/>
+          <p:nvPr/>
+        </p:nvSpPr>
+        <p:spPr>
+          <a:xfrm>
+            <a:off x="502920" y="1143000"/>
+            <a:ext cx="11064240" cy="1097280"/>
+          </a:xfrm>
+          <a:prstGeom prst="rect">
+            <a:avLst/>
+          </a:prstGeom>
+          <a:noFill/>
+        </p:spPr>
+        <p:txBody>
+          <a:bodyPr wrap="none">
+            <a:spAutoFit/>
+          </a:bodyPr>
+          <a:lstStyle/>
+          <a:p>
+            <a:r>
+              <a:rPr sz="3000" b="1">
+                <a:solidFill>
+                  <a:srgbClr val="0D1B3D"/>
+                </a:solidFill>
+              </a:rPr>
+              <a:t>AI Judgment + Verification Lab</a:t>
+            </a:r>
+          </a:p>
+        </p:txBody>
+      </p:sp>
+      <p:sp>
+        <p:nvSpPr>
+          <p:cNvPr id="5" name="TextBox 4"/>
+          <p:cNvSpPr txBox="1"/>
+          <p:nvPr/>
+        </p:nvSpPr>
+        <p:spPr>
+          <a:xfrm>
+            <a:off x="530352" y="2148840"/>
+            <a:ext cx="10789920" cy="731520"/>
+          </a:xfrm>
+          <a:prstGeom prst="rect">
+            <a:avLst/>
+          </a:prstGeom>
+          <a:noFill/>
+        </p:spPr>
+        <p:txBody>
+          <a:bodyPr wrap="none">
+            <a:spAutoFit/>
+          </a:bodyPr>
+          <a:lstStyle/>
+          <a:p>
+            <a:r>
+              <a:rPr sz="1600">
+                <a:solidFill>
+                  <a:srgbClr val="3C4655"/>
+                </a:solidFill>
+              </a:rPr>
+              <a:t>Coach Jones leads STOP - CHECK - DECIDE, AI Detective, Fix the AI, and Trust / Verify / Reject.</a:t>
+            </a:r>
+          </a:p>
+        </p:txBody>
+      </p:sp>
+      <p:sp>
+        <p:nvSpPr>
+          <p:cNvPr id="6" name="TextBox 5"/>
+          <p:cNvSpPr txBox="1"/>
+          <p:nvPr/>
+        </p:nvSpPr>
+        <p:spPr>
+          <a:xfrm>
+            <a:off x="731520" y="2971800"/>
+            <a:ext cx="10789920" cy="3017520"/>
+          </a:xfrm>
+          <a:prstGeom prst="rect">
+            <a:avLst/>
+          </a:prstGeom>
+          <a:noFill/>
+        </p:spPr>
+        <p:txBody>
+          <a:bodyPr wrap="square">
+            <a:spAutoFit/>
+          </a:bodyPr>
+          <a:lstStyle/>
+          <a:p>
+            <a:pPr>
+              <a:spcAft>
+                <a:spcPts val="800"/>
+              </a:spcAft>
+              <a:defRPr sz="1700">
+                <a:solidFill>
+                  <a:srgbClr val="192332"/>
                 </a:solidFill>
               </a:defRPr>
             </a:pPr>
             <a:r>
-              <a:t>BUILD6™ · WEEK 9 · © 2026 LINK Lake Norman, LLC · All Rights Reserved</a:t>
+              <a:t>STOP: What do I need to understand?</a:t>
+            </a:r>
+          </a:p>
+          <a:p>
+            <a:pPr>
+              <a:spcAft>
+                <a:spcPts val="800"/>
+              </a:spcAft>
+              <a:defRPr sz="1700">
+                <a:solidFill>
+                  <a:srgbClr val="192332"/>
+                </a:solidFill>
+              </a:defRPr>
+            </a:pPr>
+            <a:r>
+              <a:t>CHECK: What facts, dates, sources, assumptions, bias, privacy, or missing information must I verify?</a:t>
+            </a:r>
+          </a:p>
+          <a:p>
+            <a:pPr>
+              <a:spcAft>
+                <a:spcPts val="800"/>
+              </a:spcAft>
+              <a:defRPr sz="1700">
+                <a:solidFill>
+                  <a:srgbClr val="192332"/>
+                </a:solidFill>
+              </a:defRPr>
+            </a:pPr>
+            <a:r>
+              <a:t>DECIDE: Use, revise, verify, reject, or ask a better question - and why?</a:t>
+            </a:r>
+          </a:p>
+          <a:p>
+            <a:pPr>
+              <a:spcAft>
+                <a:spcPts val="800"/>
+              </a:spcAft>
+              <a:defRPr sz="1700">
+                <a:solidFill>
+                  <a:srgbClr val="192332"/>
+                </a:solidFill>
+              </a:defRPr>
+            </a:pPr>
+            <a:r>
+              <a:t>Create My AI Verification Checklist (5+ rules).</a:t>
             </a:r>
           </a:p>
         </p:txBody>
@@ -3600,13 +4035,13 @@
 </p:sld>
 </file>
 
-<file path=ppt/slides/slide11.xml><?xml version="1.0" encoding="utf-8"?>
+<file path=ppt/slides/slide5.xml><?xml version="1.0" encoding="utf-8"?>
 <p:sld xmlns:a="http://schemas.openxmlformats.org/drawingml/2006/main" xmlns:p="http://schemas.openxmlformats.org/presentationml/2006/main" xmlns:r="http://schemas.openxmlformats.org/officeDocument/2006/relationships">
   <p:cSld>
     <p:bg>
       <p:bgPr>
         <a:solidFill>
-          <a:srgbClr val="F5F9FA"/>
+          <a:srgbClr val="F5F7FA"/>
         </a:solidFill>
         <a:effectLst/>
       </p:bgPr>
@@ -3627,13 +4062,13 @@
         <p:spPr>
           <a:xfrm>
             <a:off x="0" y="0"/>
-            <a:ext cx="164592" cy="6858000"/>
+            <a:ext cx="12191695" cy="822960"/>
           </a:xfrm>
           <a:prstGeom prst="rect">
             <a:avLst/>
           </a:prstGeom>
           <a:solidFill>
-            <a:srgbClr val="00A6A6"/>
+            <a:srgbClr val="0D1B3D"/>
           </a:solidFill>
           <a:ln>
             <a:noFill/>
@@ -3669,8 +4104,8 @@
         </p:nvSpPr>
         <p:spPr>
           <a:xfrm>
-            <a:off x="594360" y="411480"/>
-            <a:ext cx="10972800" cy="640080"/>
+            <a:off x="411480" y="146304"/>
+            <a:ext cx="11155680" cy="502920"/>
           </a:xfrm>
           <a:prstGeom prst="rect">
             <a:avLst/>
@@ -3683,16 +4118,13 @@
           </a:bodyPr>
           <a:lstStyle/>
           <a:p>
-            <a:pPr>
-              <a:defRPr sz="2900" b="1">
-                <a:solidFill>
-                  <a:srgbClr val="062B3F"/>
-                </a:solidFill>
-                <a:latin typeface="Aptos Display"/>
-              </a:defRPr>
-            </a:pPr>
-            <a:r>
-              <a:t>Capstone Connection</a:t>
+            <a:r>
+              <a:rPr sz="1200" b="1">
+                <a:solidFill>
+                  <a:srgbClr val="F2B705"/>
+                </a:solidFill>
+              </a:rPr>
+              <a:t>THURSDAY</a:t>
             </a:r>
           </a:p>
         </p:txBody>
@@ -3705,8 +4137,8 @@
         </p:nvSpPr>
         <p:spPr>
           <a:xfrm>
-            <a:off x="822960" y="1463040"/>
-            <a:ext cx="10561320" cy="4480560"/>
+            <a:off x="502920" y="1143000"/>
+            <a:ext cx="11064240" cy="1097280"/>
           </a:xfrm>
           <a:prstGeom prst="rect">
             <a:avLst/>
@@ -3714,6 +4146,72 @@
           <a:noFill/>
         </p:spPr>
         <p:txBody>
+          <a:bodyPr wrap="none">
+            <a:spAutoFit/>
+          </a:bodyPr>
+          <a:lstStyle/>
+          <a:p>
+            <a:r>
+              <a:rPr sz="3000" b="1">
+                <a:solidFill>
+                  <a:srgbClr val="0D1B3D"/>
+                </a:solidFill>
+              </a:rPr>
+              <a:t>AI Project Studio</a:t>
+            </a:r>
+          </a:p>
+        </p:txBody>
+      </p:sp>
+      <p:sp>
+        <p:nvSpPr>
+          <p:cNvPr id="5" name="TextBox 4"/>
+          <p:cNvSpPr txBox="1"/>
+          <p:nvPr/>
+        </p:nvSpPr>
+        <p:spPr>
+          <a:xfrm>
+            <a:off x="530352" y="2148840"/>
+            <a:ext cx="10789920" cy="731520"/>
+          </a:xfrm>
+          <a:prstGeom prst="rect">
+            <a:avLst/>
+          </a:prstGeom>
+          <a:noFill/>
+        </p:spPr>
+        <p:txBody>
+          <a:bodyPr wrap="none">
+            <a:spAutoFit/>
+          </a:bodyPr>
+          <a:lstStyle/>
+          <a:p>
+            <a:r>
+              <a:rPr sz="1600">
+                <a:solidFill>
+                  <a:srgbClr val="3C4655"/>
+                </a:solidFill>
+              </a:rPr>
+              <a:t>Use AI on a real BUILD6 project. Document your prompt, output, changes, rejections, verification, and human contribution.</a:t>
+            </a:r>
+          </a:p>
+        </p:txBody>
+      </p:sp>
+      <p:sp>
+        <p:nvSpPr>
+          <p:cNvPr id="6" name="TextBox 5"/>
+          <p:cNvSpPr txBox="1"/>
+          <p:nvPr/>
+        </p:nvSpPr>
+        <p:spPr>
+          <a:xfrm>
+            <a:off x="731520" y="2971800"/>
+            <a:ext cx="10789920" cy="3017520"/>
+          </a:xfrm>
+          <a:prstGeom prst="rect">
+            <a:avLst/>
+          </a:prstGeom>
+          <a:noFill/>
+        </p:spPr>
+        <p:txBody>
           <a:bodyPr wrap="square">
             <a:spAutoFit/>
           </a:bodyPr>
@@ -3721,85 +4219,122 @@
           <a:p>
             <a:pPr>
               <a:spcAft>
-                <a:spcPts val="1400"/>
+                <a:spcPts val="800"/>
               </a:spcAft>
-              <a:defRPr sz="2100">
-                <a:solidFill>
-                  <a:srgbClr val="1B262C"/>
-                </a:solidFill>
-                <a:latin typeface="Aptos"/>
+              <a:defRPr sz="1700">
+                <a:solidFill>
+                  <a:srgbClr val="192332"/>
+                </a:solidFill>
               </a:defRPr>
             </a:pPr>
             <a:r>
-              <a:t>What changed in how I see myself?</a:t>
+              <a:t>What I asked</a:t>
             </a:r>
           </a:p>
           <a:p>
             <a:pPr>
               <a:spcAft>
-                <a:spcPts val="1400"/>
+                <a:spcPts val="800"/>
               </a:spcAft>
-              <a:defRPr sz="2100">
-                <a:solidFill>
-                  <a:srgbClr val="1B262C"/>
-                </a:solidFill>
-                <a:latin typeface="Aptos"/>
+              <a:defRPr sz="1700">
+                <a:solidFill>
+                  <a:srgbClr val="192332"/>
+                </a:solidFill>
               </a:defRPr>
             </a:pPr>
             <a:r>
-              <a:t>What changed in how I see work or opportunity?</a:t>
+              <a:t>What AI gave me</a:t>
             </a:r>
           </a:p>
           <a:p>
             <a:pPr>
               <a:spcAft>
-                <a:spcPts val="1400"/>
+                <a:spcPts val="800"/>
               </a:spcAft>
-              <a:defRPr sz="2100">
-                <a:solidFill>
-                  <a:srgbClr val="1B262C"/>
-                </a:solidFill>
-                <a:latin typeface="Aptos"/>
+              <a:defRPr sz="1700">
+                <a:solidFill>
+                  <a:srgbClr val="192332"/>
+                </a:solidFill>
               </a:defRPr>
             </a:pPr>
             <a:r>
-              <a:t>Which piece of evidence belongs in my final story?</a:t>
+              <a:t>What I changed / rejected / corrected</a:t>
             </a:r>
           </a:p>
           <a:p>
             <a:pPr>
               <a:spcAft>
-                <a:spcPts val="1400"/>
+                <a:spcPts val="800"/>
               </a:spcAft>
-              <a:defRPr sz="2100">
-                <a:solidFill>
-                  <a:srgbClr val="1B262C"/>
-                </a:solidFill>
-                <a:latin typeface="Aptos"/>
+              <a:defRPr sz="1700">
+                <a:solidFill>
+                  <a:srgbClr val="192332"/>
+                </a:solidFill>
               </a:defRPr>
             </a:pPr>
             <a:r>
-              <a:t>Mark it now so you do not have to reconstruct the semester later.</a:t>
-            </a:r>
-          </a:p>
-        </p:txBody>
-      </p:sp>
-      <p:sp>
-        <p:nvSpPr>
-          <p:cNvPr id="5" name="Rectangle 4"/>
+              <a:t>What I verified and how</a:t>
+            </a:r>
+          </a:p>
+          <a:p>
+            <a:pPr>
+              <a:spcAft>
+                <a:spcPts val="800"/>
+              </a:spcAft>
+              <a:defRPr sz="1700">
+                <a:solidFill>
+                  <a:srgbClr val="192332"/>
+                </a:solidFill>
+              </a:defRPr>
+            </a:pPr>
+            <a:r>
+              <a:t>What I contributed that AI could not replace</a:t>
+            </a:r>
+          </a:p>
+        </p:txBody>
+      </p:sp>
+    </p:spTree>
+  </p:cSld>
+  <p:clrMapOvr>
+    <a:masterClrMapping/>
+  </p:clrMapOvr>
+</p:sld>
+</file>
+
+<file path=ppt/slides/slide6.xml><?xml version="1.0" encoding="utf-8"?>
+<p:sld xmlns:a="http://schemas.openxmlformats.org/drawingml/2006/main" xmlns:p="http://schemas.openxmlformats.org/presentationml/2006/main" xmlns:r="http://schemas.openxmlformats.org/officeDocument/2006/relationships">
+  <p:cSld>
+    <p:bg>
+      <p:bgPr>
+        <a:solidFill>
+          <a:srgbClr val="F5F7FA"/>
+        </a:solidFill>
+        <a:effectLst/>
+      </p:bgPr>
+    </p:bg>
+    <p:spTree>
+      <p:nvGrpSpPr>
+        <p:cNvPr id="1" name=""/>
+        <p:cNvGrpSpPr/>
+        <p:nvPr/>
+      </p:nvGrpSpPr>
+      <p:grpSpPr/>
+      <p:sp>
+        <p:nvSpPr>
+          <p:cNvPr id="2" name="Rectangle 1"/>
           <p:cNvSpPr/>
           <p:nvPr/>
         </p:nvSpPr>
         <p:spPr>
           <a:xfrm>
-            <a:off x="0" y="6446520"/>
-            <a:ext cx="12191695" cy="411480"/>
+            <a:off x="0" y="0"/>
+            <a:ext cx="12191695" cy="822960"/>
           </a:xfrm>
           <a:prstGeom prst="rect">
             <a:avLst/>
           </a:prstGeom>
           <a:solidFill>
-            <a:srgbClr val="062B3F"/>
+            <a:srgbClr val="0D1B3D"/>
           </a:solidFill>
           <a:ln>
             <a:noFill/>
@@ -3829,14 +4364,14 @@
       </p:sp>
       <p:sp>
         <p:nvSpPr>
-          <p:cNvPr id="6" name="TextBox 5"/>
+          <p:cNvPr id="3" name="TextBox 2"/>
           <p:cNvSpPr txBox="1"/>
           <p:nvPr/>
         </p:nvSpPr>
         <p:spPr>
           <a:xfrm>
-            <a:off x="457200" y="6510528"/>
-            <a:ext cx="11247120" cy="182880"/>
+            <a:off x="411480" y="146304"/>
+            <a:ext cx="11155680" cy="502920"/>
           </a:xfrm>
           <a:prstGeom prst="rect">
             <a:avLst/>
@@ -3849,98 +4384,27 @@
           </a:bodyPr>
           <a:lstStyle/>
           <a:p>
-            <a:pPr algn="ctr">
-              <a:defRPr sz="900">
-                <a:solidFill>
-                  <a:srgbClr val="FFFFFF"/>
-                </a:solidFill>
-              </a:defRPr>
-            </a:pPr>
-            <a:r>
-              <a:t>BUILD6™ · WEEK 9 · © 2026 LINK Lake Norman, LLC · All Rights Reserved</a:t>
-            </a:r>
-          </a:p>
-        </p:txBody>
-      </p:sp>
-    </p:spTree>
-  </p:cSld>
-  <p:clrMapOvr>
-    <a:masterClrMapping/>
-  </p:clrMapOvr>
-</p:sld>
-</file>
-
-<file path=ppt/slides/slide12.xml><?xml version="1.0" encoding="utf-8"?>
-<p:sld xmlns:a="http://schemas.openxmlformats.org/drawingml/2006/main" xmlns:p="http://schemas.openxmlformats.org/presentationml/2006/main" xmlns:r="http://schemas.openxmlformats.org/officeDocument/2006/relationships">
-  <p:cSld>
-    <p:bg>
-      <p:bgPr>
-        <a:solidFill>
-          <a:srgbClr val="F5F9FA"/>
-        </a:solidFill>
-        <a:effectLst/>
-      </p:bgPr>
-    </p:bg>
-    <p:spTree>
-      <p:nvGrpSpPr>
-        <p:cNvPr id="1" name=""/>
-        <p:cNvGrpSpPr/>
-        <p:nvPr/>
-      </p:nvGrpSpPr>
-      <p:grpSpPr/>
-      <p:sp>
-        <p:nvSpPr>
-          <p:cNvPr id="2" name="Rectangle 1"/>
-          <p:cNvSpPr/>
-          <p:nvPr/>
-        </p:nvSpPr>
-        <p:spPr>
-          <a:xfrm>
-            <a:off x="0" y="0"/>
-            <a:ext cx="164592" cy="6858000"/>
-          </a:xfrm>
-          <a:prstGeom prst="rect">
-            <a:avLst/>
-          </a:prstGeom>
-          <a:solidFill>
-            <a:srgbClr val="00A6A6"/>
-          </a:solidFill>
-          <a:ln>
-            <a:noFill/>
-          </a:ln>
-        </p:spPr>
-        <p:style>
-          <a:lnRef idx="1">
-            <a:schemeClr val="accent1"/>
-          </a:lnRef>
-          <a:fillRef idx="3">
-            <a:schemeClr val="accent1"/>
-          </a:fillRef>
-          <a:effectRef idx="2">
-            <a:schemeClr val="accent1"/>
-          </a:effectRef>
-          <a:fontRef idx="minor">
-            <a:schemeClr val="lt1"/>
-          </a:fontRef>
-        </p:style>
-        <p:txBody>
-          <a:bodyPr rtlCol="0" anchor="ctr"/>
-          <a:lstStyle/>
-          <a:p>
-            <a:pPr algn="ctr"/>
-          </a:p>
-        </p:txBody>
-      </p:sp>
-      <p:sp>
-        <p:nvSpPr>
-          <p:cNvPr id="3" name="TextBox 2"/>
+            <a:r>
+              <a:rPr sz="1200" b="1">
+                <a:solidFill>
+                  <a:srgbClr val="F2B705"/>
+                </a:solidFill>
+              </a:rPr>
+              <a:t>FRIDAY</a:t>
+            </a:r>
+          </a:p>
+        </p:txBody>
+      </p:sp>
+      <p:sp>
+        <p:nvSpPr>
+          <p:cNvPr id="4" name="TextBox 3"/>
           <p:cNvSpPr txBox="1"/>
           <p:nvPr/>
         </p:nvSpPr>
         <p:spPr>
           <a:xfrm>
-            <a:off x="594360" y="411480"/>
-            <a:ext cx="10972800" cy="640080"/>
+            <a:off x="502920" y="1143000"/>
+            <a:ext cx="11064240" cy="1097280"/>
           </a:xfrm>
           <a:prstGeom prst="rect">
             <a:avLst/>
@@ -3953,30 +4417,27 @@
           </a:bodyPr>
           <a:lstStyle/>
           <a:p>
-            <a:pPr>
-              <a:defRPr sz="2900" b="1">
-                <a:solidFill>
-                  <a:srgbClr val="062B3F"/>
-                </a:solidFill>
-                <a:latin typeface="Aptos Display"/>
-              </a:defRPr>
-            </a:pPr>
-            <a:r>
-              <a:t>What Comes Next</a:t>
-            </a:r>
-          </a:p>
-        </p:txBody>
-      </p:sp>
-      <p:sp>
-        <p:nvSpPr>
-          <p:cNvPr id="4" name="TextBox 3"/>
+            <a:r>
+              <a:rPr sz="3000" b="1">
+                <a:solidFill>
+                  <a:srgbClr val="0D1B3D"/>
+                </a:solidFill>
+              </a:rPr>
+              <a:t>Friday Closeout</a:t>
+            </a:r>
+          </a:p>
+        </p:txBody>
+      </p:sp>
+      <p:sp>
+        <p:nvSpPr>
+          <p:cNvPr id="5" name="TextBox 4"/>
           <p:cNvSpPr txBox="1"/>
           <p:nvPr/>
         </p:nvSpPr>
         <p:spPr>
           <a:xfrm>
-            <a:off x="822960" y="1463040"/>
-            <a:ext cx="10561320" cy="4480560"/>
+            <a:off x="731520" y="2011680"/>
+            <a:ext cx="10789920" cy="4297680"/>
           </a:xfrm>
           <a:prstGeom prst="rect">
             <a:avLst/>
@@ -3991,2191 +4452,46 @@
           <a:p>
             <a:pPr>
               <a:spcAft>
-                <a:spcPts val="1400"/>
+                <a:spcPts val="1000"/>
               </a:spcAft>
-              <a:defRPr sz="2100">
-                <a:solidFill>
-                  <a:srgbClr val="1B262C"/>
-                </a:solidFill>
-                <a:latin typeface="Aptos"/>
+              <a:defRPr sz="1600">
+                <a:solidFill>
+                  <a:srgbClr val="192332"/>
+                </a:solidFill>
               </a:defRPr>
             </a:pPr>
             <a:r>
-              <a:t>Use your story bank when professional questions become harder and less predictable.</a:t>
+              <a:t>What are my rules for using AI professionally, and which human skill do I want to strengthen because AI exists?</a:t>
             </a:r>
           </a:p>
           <a:p>
             <a:pPr>
               <a:spcAft>
-                <a:spcPts val="1400"/>
+                <a:spcPts val="1000"/>
               </a:spcAft>
-              <a:defRPr sz="2100">
-                <a:solidFill>
-                  <a:srgbClr val="1B262C"/>
-                </a:solidFill>
-                <a:latin typeface="Aptos"/>
+              <a:defRPr sz="1600">
+                <a:solidFill>
+                  <a:srgbClr val="192332"/>
+                </a:solidFill>
               </a:defRPr>
             </a:pPr>
             <a:r>
-              <a:t>Complete the weekly reflection.</a:t>
+              <a:t>Portfolio artifact: AI Verification Checklist + Human/AI Project Evidence + Professional AI Rules</a:t>
             </a:r>
           </a:p>
           <a:p>
             <a:pPr>
               <a:spcAft>
-                <a:spcPts val="1400"/>
+                <a:spcPts val="1000"/>
               </a:spcAft>
-              <a:defRPr sz="2100">
-                <a:solidFill>
-                  <a:srgbClr val="1B262C"/>
-                </a:solidFill>
-                <a:latin typeface="Aptos"/>
+              <a:defRPr sz="1600">
+                <a:solidFill>
+                  <a:srgbClr val="192332"/>
+                </a:solidFill>
               </a:defRPr>
             </a:pPr>
             <a:r>
-              <a:t>Save your evidence.</a:t>
-            </a:r>
-          </a:p>
-          <a:p>
-            <a:pPr>
-              <a:spcAft>
-                <a:spcPts val="1400"/>
-              </a:spcAft>
-              <a:defRPr sz="2100">
-                <a:solidFill>
-                  <a:srgbClr val="1B262C"/>
-                </a:solidFill>
-                <a:latin typeface="Aptos"/>
-              </a:defRPr>
-            </a:pPr>
-            <a:r>
-              <a:t>Keep building the story of who you are becoming.</a:t>
-            </a:r>
-          </a:p>
-        </p:txBody>
-      </p:sp>
-      <p:sp>
-        <p:nvSpPr>
-          <p:cNvPr id="5" name="Rectangle 4"/>
-          <p:cNvSpPr/>
-          <p:nvPr/>
-        </p:nvSpPr>
-        <p:spPr>
-          <a:xfrm>
-            <a:off x="0" y="6446520"/>
-            <a:ext cx="12191695" cy="411480"/>
-          </a:xfrm>
-          <a:prstGeom prst="rect">
-            <a:avLst/>
-          </a:prstGeom>
-          <a:solidFill>
-            <a:srgbClr val="062B3F"/>
-          </a:solidFill>
-          <a:ln>
-            <a:noFill/>
-          </a:ln>
-        </p:spPr>
-        <p:style>
-          <a:lnRef idx="1">
-            <a:schemeClr val="accent1"/>
-          </a:lnRef>
-          <a:fillRef idx="3">
-            <a:schemeClr val="accent1"/>
-          </a:fillRef>
-          <a:effectRef idx="2">
-            <a:schemeClr val="accent1"/>
-          </a:effectRef>
-          <a:fontRef idx="minor">
-            <a:schemeClr val="lt1"/>
-          </a:fontRef>
-        </p:style>
-        <p:txBody>
-          <a:bodyPr rtlCol="0" anchor="ctr"/>
-          <a:lstStyle/>
-          <a:p>
-            <a:pPr algn="ctr"/>
-          </a:p>
-        </p:txBody>
-      </p:sp>
-      <p:sp>
-        <p:nvSpPr>
-          <p:cNvPr id="6" name="TextBox 5"/>
-          <p:cNvSpPr txBox="1"/>
-          <p:nvPr/>
-        </p:nvSpPr>
-        <p:spPr>
-          <a:xfrm>
-            <a:off x="457200" y="6510528"/>
-            <a:ext cx="11247120" cy="182880"/>
-          </a:xfrm>
-          <a:prstGeom prst="rect">
-            <a:avLst/>
-          </a:prstGeom>
-          <a:noFill/>
-        </p:spPr>
-        <p:txBody>
-          <a:bodyPr wrap="none">
-            <a:spAutoFit/>
-          </a:bodyPr>
-          <a:lstStyle/>
-          <a:p>
-            <a:pPr algn="ctr">
-              <a:defRPr sz="900">
-                <a:solidFill>
-                  <a:srgbClr val="FFFFFF"/>
-                </a:solidFill>
-              </a:defRPr>
-            </a:pPr>
-            <a:r>
-              <a:t>BUILD6™ · WEEK 9 · © 2026 LINK Lake Norman, LLC · All Rights Reserved</a:t>
-            </a:r>
-          </a:p>
-        </p:txBody>
-      </p:sp>
-    </p:spTree>
-  </p:cSld>
-  <p:clrMapOvr>
-    <a:masterClrMapping/>
-  </p:clrMapOvr>
-</p:sld>
-</file>
-
-<file path=ppt/slides/slide2.xml><?xml version="1.0" encoding="utf-8"?>
-<p:sld xmlns:a="http://schemas.openxmlformats.org/drawingml/2006/main" xmlns:p="http://schemas.openxmlformats.org/presentationml/2006/main" xmlns:r="http://schemas.openxmlformats.org/officeDocument/2006/relationships">
-  <p:cSld>
-    <p:bg>
-      <p:bgPr>
-        <a:solidFill>
-          <a:srgbClr val="F5F9FA"/>
-        </a:solidFill>
-        <a:effectLst/>
-      </p:bgPr>
-    </p:bg>
-    <p:spTree>
-      <p:nvGrpSpPr>
-        <p:cNvPr id="1" name=""/>
-        <p:cNvGrpSpPr/>
-        <p:nvPr/>
-      </p:nvGrpSpPr>
-      <p:grpSpPr/>
-      <p:sp>
-        <p:nvSpPr>
-          <p:cNvPr id="2" name="Rectangle 1"/>
-          <p:cNvSpPr/>
-          <p:nvPr/>
-        </p:nvSpPr>
-        <p:spPr>
-          <a:xfrm>
-            <a:off x="0" y="0"/>
-            <a:ext cx="164592" cy="6858000"/>
-          </a:xfrm>
-          <a:prstGeom prst="rect">
-            <a:avLst/>
-          </a:prstGeom>
-          <a:solidFill>
-            <a:srgbClr val="00A6A6"/>
-          </a:solidFill>
-          <a:ln>
-            <a:noFill/>
-          </a:ln>
-        </p:spPr>
-        <p:style>
-          <a:lnRef idx="1">
-            <a:schemeClr val="accent1"/>
-          </a:lnRef>
-          <a:fillRef idx="3">
-            <a:schemeClr val="accent1"/>
-          </a:fillRef>
-          <a:effectRef idx="2">
-            <a:schemeClr val="accent1"/>
-          </a:effectRef>
-          <a:fontRef idx="minor">
-            <a:schemeClr val="lt1"/>
-          </a:fontRef>
-        </p:style>
-        <p:txBody>
-          <a:bodyPr rtlCol="0" anchor="ctr"/>
-          <a:lstStyle/>
-          <a:p>
-            <a:pPr algn="ctr"/>
-          </a:p>
-        </p:txBody>
-      </p:sp>
-      <p:sp>
-        <p:nvSpPr>
-          <p:cNvPr id="3" name="TextBox 2"/>
-          <p:cNvSpPr txBox="1"/>
-          <p:nvPr/>
-        </p:nvSpPr>
-        <p:spPr>
-          <a:xfrm>
-            <a:off x="594360" y="411480"/>
-            <a:ext cx="10972800" cy="640080"/>
-          </a:xfrm>
-          <a:prstGeom prst="rect">
-            <a:avLst/>
-          </a:prstGeom>
-          <a:noFill/>
-        </p:spPr>
-        <p:txBody>
-          <a:bodyPr wrap="none">
-            <a:spAutoFit/>
-          </a:bodyPr>
-          <a:lstStyle/>
-          <a:p>
-            <a:pPr>
-              <a:defRPr sz="2900" b="1">
-                <a:solidFill>
-                  <a:srgbClr val="062B3F"/>
-                </a:solidFill>
-                <a:latin typeface="Aptos Display"/>
-              </a:defRPr>
-            </a:pPr>
-            <a:r>
-              <a:t>Why This Week Matters</a:t>
-            </a:r>
-          </a:p>
-        </p:txBody>
-      </p:sp>
-      <p:sp>
-        <p:nvSpPr>
-          <p:cNvPr id="4" name="TextBox 3"/>
-          <p:cNvSpPr txBox="1"/>
-          <p:nvPr/>
-        </p:nvSpPr>
-        <p:spPr>
-          <a:xfrm>
-            <a:off x="822960" y="1463040"/>
-            <a:ext cx="10561320" cy="4480560"/>
-          </a:xfrm>
-          <a:prstGeom prst="rect">
-            <a:avLst/>
-          </a:prstGeom>
-          <a:noFill/>
-        </p:spPr>
-        <p:txBody>
-          <a:bodyPr wrap="square">
-            <a:spAutoFit/>
-          </a:bodyPr>
-          <a:lstStyle/>
-          <a:p>
-            <a:pPr>
-              <a:spcAft>
-                <a:spcPts val="1400"/>
-              </a:spcAft>
-              <a:defRPr sz="2100">
-                <a:solidFill>
-                  <a:srgbClr val="1B262C"/>
-                </a:solidFill>
-                <a:latin typeface="Aptos"/>
-              </a:defRPr>
-            </a:pPr>
-            <a:r>
-              <a:t>A strong resume and interview are built from specific evidence, not generic claims.</a:t>
-            </a:r>
-          </a:p>
-        </p:txBody>
-      </p:sp>
-      <p:sp>
-        <p:nvSpPr>
-          <p:cNvPr id="5" name="Rectangle 4"/>
-          <p:cNvSpPr/>
-          <p:nvPr/>
-        </p:nvSpPr>
-        <p:spPr>
-          <a:xfrm>
-            <a:off x="0" y="6446520"/>
-            <a:ext cx="12191695" cy="411480"/>
-          </a:xfrm>
-          <a:prstGeom prst="rect">
-            <a:avLst/>
-          </a:prstGeom>
-          <a:solidFill>
-            <a:srgbClr val="062B3F"/>
-          </a:solidFill>
-          <a:ln>
-            <a:noFill/>
-          </a:ln>
-        </p:spPr>
-        <p:style>
-          <a:lnRef idx="1">
-            <a:schemeClr val="accent1"/>
-          </a:lnRef>
-          <a:fillRef idx="3">
-            <a:schemeClr val="accent1"/>
-          </a:fillRef>
-          <a:effectRef idx="2">
-            <a:schemeClr val="accent1"/>
-          </a:effectRef>
-          <a:fontRef idx="minor">
-            <a:schemeClr val="lt1"/>
-          </a:fontRef>
-        </p:style>
-        <p:txBody>
-          <a:bodyPr rtlCol="0" anchor="ctr"/>
-          <a:lstStyle/>
-          <a:p>
-            <a:pPr algn="ctr"/>
-          </a:p>
-        </p:txBody>
-      </p:sp>
-      <p:sp>
-        <p:nvSpPr>
-          <p:cNvPr id="6" name="TextBox 5"/>
-          <p:cNvSpPr txBox="1"/>
-          <p:nvPr/>
-        </p:nvSpPr>
-        <p:spPr>
-          <a:xfrm>
-            <a:off x="457200" y="6510528"/>
-            <a:ext cx="11247120" cy="182880"/>
-          </a:xfrm>
-          <a:prstGeom prst="rect">
-            <a:avLst/>
-          </a:prstGeom>
-          <a:noFill/>
-        </p:spPr>
-        <p:txBody>
-          <a:bodyPr wrap="none">
-            <a:spAutoFit/>
-          </a:bodyPr>
-          <a:lstStyle/>
-          <a:p>
-            <a:pPr algn="ctr">
-              <a:defRPr sz="900">
-                <a:solidFill>
-                  <a:srgbClr val="FFFFFF"/>
-                </a:solidFill>
-              </a:defRPr>
-            </a:pPr>
-            <a:r>
-              <a:t>BUILD6™ · WEEK 9 · © 2026 LINK Lake Norman, LLC · All Rights Reserved</a:t>
-            </a:r>
-          </a:p>
-        </p:txBody>
-      </p:sp>
-    </p:spTree>
-  </p:cSld>
-  <p:clrMapOvr>
-    <a:masterClrMapping/>
-  </p:clrMapOvr>
-</p:sld>
-</file>
-
-<file path=ppt/slides/slide3.xml><?xml version="1.0" encoding="utf-8"?>
-<p:sld xmlns:a="http://schemas.openxmlformats.org/drawingml/2006/main" xmlns:p="http://schemas.openxmlformats.org/presentationml/2006/main" xmlns:r="http://schemas.openxmlformats.org/officeDocument/2006/relationships">
-  <p:cSld>
-    <p:bg>
-      <p:bgPr>
-        <a:solidFill>
-          <a:srgbClr val="F5F9FA"/>
-        </a:solidFill>
-        <a:effectLst/>
-      </p:bgPr>
-    </p:bg>
-    <p:spTree>
-      <p:nvGrpSpPr>
-        <p:cNvPr id="1" name=""/>
-        <p:cNvGrpSpPr/>
-        <p:nvPr/>
-      </p:nvGrpSpPr>
-      <p:grpSpPr/>
-      <p:sp>
-        <p:nvSpPr>
-          <p:cNvPr id="2" name="Rectangle 1"/>
-          <p:cNvSpPr/>
-          <p:nvPr/>
-        </p:nvSpPr>
-        <p:spPr>
-          <a:xfrm>
-            <a:off x="0" y="0"/>
-            <a:ext cx="164592" cy="6858000"/>
-          </a:xfrm>
-          <a:prstGeom prst="rect">
-            <a:avLst/>
-          </a:prstGeom>
-          <a:solidFill>
-            <a:srgbClr val="00A6A6"/>
-          </a:solidFill>
-          <a:ln>
-            <a:noFill/>
-          </a:ln>
-        </p:spPr>
-        <p:style>
-          <a:lnRef idx="1">
-            <a:schemeClr val="accent1"/>
-          </a:lnRef>
-          <a:fillRef idx="3">
-            <a:schemeClr val="accent1"/>
-          </a:fillRef>
-          <a:effectRef idx="2">
-            <a:schemeClr val="accent1"/>
-          </a:effectRef>
-          <a:fontRef idx="minor">
-            <a:schemeClr val="lt1"/>
-          </a:fontRef>
-        </p:style>
-        <p:txBody>
-          <a:bodyPr rtlCol="0" anchor="ctr"/>
-          <a:lstStyle/>
-          <a:p>
-            <a:pPr algn="ctr"/>
-          </a:p>
-        </p:txBody>
-      </p:sp>
-      <p:sp>
-        <p:nvSpPr>
-          <p:cNvPr id="3" name="TextBox 2"/>
-          <p:cNvSpPr txBox="1"/>
-          <p:nvPr/>
-        </p:nvSpPr>
-        <p:spPr>
-          <a:xfrm>
-            <a:off x="594360" y="411480"/>
-            <a:ext cx="10972800" cy="640080"/>
-          </a:xfrm>
-          <a:prstGeom prst="rect">
-            <a:avLst/>
-          </a:prstGeom>
-          <a:noFill/>
-        </p:spPr>
-        <p:txBody>
-          <a:bodyPr wrap="none">
-            <a:spAutoFit/>
-          </a:bodyPr>
-          <a:lstStyle/>
-          <a:p>
-            <a:pPr>
-              <a:defRPr sz="2900" b="1">
-                <a:solidFill>
-                  <a:srgbClr val="062B3F"/>
-                </a:solidFill>
-                <a:latin typeface="Aptos Display"/>
-              </a:defRPr>
-            </a:pPr>
-            <a:r>
-              <a:t>BUILD6 Skills in Focus</a:t>
-            </a:r>
-          </a:p>
-        </p:txBody>
-      </p:sp>
-      <p:sp>
-        <p:nvSpPr>
-          <p:cNvPr id="4" name="TextBox 3"/>
-          <p:cNvSpPr txBox="1"/>
-          <p:nvPr/>
-        </p:nvSpPr>
-        <p:spPr>
-          <a:xfrm>
-            <a:off x="822960" y="1463040"/>
-            <a:ext cx="10561320" cy="4480560"/>
-          </a:xfrm>
-          <a:prstGeom prst="rect">
-            <a:avLst/>
-          </a:prstGeom>
-          <a:noFill/>
-        </p:spPr>
-        <p:txBody>
-          <a:bodyPr wrap="square">
-            <a:spAutoFit/>
-          </a:bodyPr>
-          <a:lstStyle/>
-          <a:p>
-            <a:pPr>
-              <a:spcAft>
-                <a:spcPts val="1400"/>
-              </a:spcAft>
-              <a:defRPr sz="2100">
-                <a:solidFill>
-                  <a:srgbClr val="1B262C"/>
-                </a:solidFill>
-                <a:latin typeface="Aptos"/>
-              </a:defRPr>
-            </a:pPr>
-            <a:r>
-              <a:t>Resume storytelling</a:t>
-            </a:r>
-          </a:p>
-          <a:p>
-            <a:pPr>
-              <a:spcAft>
-                <a:spcPts val="1400"/>
-              </a:spcAft>
-              <a:defRPr sz="2100">
-                <a:solidFill>
-                  <a:srgbClr val="1B262C"/>
-                </a:solidFill>
-                <a:latin typeface="Aptos"/>
-              </a:defRPr>
-            </a:pPr>
-            <a:r>
-              <a:t>Interview preparation</a:t>
-            </a:r>
-          </a:p>
-          <a:p>
-            <a:pPr>
-              <a:spcAft>
-                <a:spcPts val="1400"/>
-              </a:spcAft>
-              <a:defRPr sz="2100">
-                <a:solidFill>
-                  <a:srgbClr val="1B262C"/>
-                </a:solidFill>
-                <a:latin typeface="Aptos"/>
-              </a:defRPr>
-            </a:pPr>
-            <a:r>
-              <a:t>Professional confidence</a:t>
-            </a:r>
-          </a:p>
-          <a:p>
-            <a:pPr>
-              <a:spcAft>
-                <a:spcPts val="1400"/>
-              </a:spcAft>
-              <a:defRPr sz="2100">
-                <a:solidFill>
-                  <a:srgbClr val="1B262C"/>
-                </a:solidFill>
-                <a:latin typeface="Aptos"/>
-              </a:defRPr>
-            </a:pPr>
-            <a:r>
-              <a:t>Evidence-based communication</a:t>
-            </a:r>
-          </a:p>
-        </p:txBody>
-      </p:sp>
-      <p:sp>
-        <p:nvSpPr>
-          <p:cNvPr id="5" name="Rectangle 4"/>
-          <p:cNvSpPr/>
-          <p:nvPr/>
-        </p:nvSpPr>
-        <p:spPr>
-          <a:xfrm>
-            <a:off x="0" y="6446520"/>
-            <a:ext cx="12191695" cy="411480"/>
-          </a:xfrm>
-          <a:prstGeom prst="rect">
-            <a:avLst/>
-          </a:prstGeom>
-          <a:solidFill>
-            <a:srgbClr val="062B3F"/>
-          </a:solidFill>
-          <a:ln>
-            <a:noFill/>
-          </a:ln>
-        </p:spPr>
-        <p:style>
-          <a:lnRef idx="1">
-            <a:schemeClr val="accent1"/>
-          </a:lnRef>
-          <a:fillRef idx="3">
-            <a:schemeClr val="accent1"/>
-          </a:fillRef>
-          <a:effectRef idx="2">
-            <a:schemeClr val="accent1"/>
-          </a:effectRef>
-          <a:fontRef idx="minor">
-            <a:schemeClr val="lt1"/>
-          </a:fontRef>
-        </p:style>
-        <p:txBody>
-          <a:bodyPr rtlCol="0" anchor="ctr"/>
-          <a:lstStyle/>
-          <a:p>
-            <a:pPr algn="ctr"/>
-          </a:p>
-        </p:txBody>
-      </p:sp>
-      <p:sp>
-        <p:nvSpPr>
-          <p:cNvPr id="6" name="TextBox 5"/>
-          <p:cNvSpPr txBox="1"/>
-          <p:nvPr/>
-        </p:nvSpPr>
-        <p:spPr>
-          <a:xfrm>
-            <a:off x="457200" y="6510528"/>
-            <a:ext cx="11247120" cy="182880"/>
-          </a:xfrm>
-          <a:prstGeom prst="rect">
-            <a:avLst/>
-          </a:prstGeom>
-          <a:noFill/>
-        </p:spPr>
-        <p:txBody>
-          <a:bodyPr wrap="none">
-            <a:spAutoFit/>
-          </a:bodyPr>
-          <a:lstStyle/>
-          <a:p>
-            <a:pPr algn="ctr">
-              <a:defRPr sz="900">
-                <a:solidFill>
-                  <a:srgbClr val="FFFFFF"/>
-                </a:solidFill>
-              </a:defRPr>
-            </a:pPr>
-            <a:r>
-              <a:t>BUILD6™ · WEEK 9 · © 2026 LINK Lake Norman, LLC · All Rights Reserved</a:t>
-            </a:r>
-          </a:p>
-        </p:txBody>
-      </p:sp>
-    </p:spTree>
-  </p:cSld>
-  <p:clrMapOvr>
-    <a:masterClrMapping/>
-  </p:clrMapOvr>
-</p:sld>
-</file>
-
-<file path=ppt/slides/slide4.xml><?xml version="1.0" encoding="utf-8"?>
-<p:sld xmlns:a="http://schemas.openxmlformats.org/drawingml/2006/main" xmlns:p="http://schemas.openxmlformats.org/presentationml/2006/main" xmlns:r="http://schemas.openxmlformats.org/officeDocument/2006/relationships">
-  <p:cSld>
-    <p:bg>
-      <p:bgPr>
-        <a:solidFill>
-          <a:srgbClr val="F5F9FA"/>
-        </a:solidFill>
-        <a:effectLst/>
-      </p:bgPr>
-    </p:bg>
-    <p:spTree>
-      <p:nvGrpSpPr>
-        <p:cNvPr id="1" name=""/>
-        <p:cNvGrpSpPr/>
-        <p:nvPr/>
-      </p:nvGrpSpPr>
-      <p:grpSpPr/>
-      <p:sp>
-        <p:nvSpPr>
-          <p:cNvPr id="2" name="Rectangle 1"/>
-          <p:cNvSpPr/>
-          <p:nvPr/>
-        </p:nvSpPr>
-        <p:spPr>
-          <a:xfrm>
-            <a:off x="0" y="0"/>
-            <a:ext cx="164592" cy="6858000"/>
-          </a:xfrm>
-          <a:prstGeom prst="rect">
-            <a:avLst/>
-          </a:prstGeom>
-          <a:solidFill>
-            <a:srgbClr val="00A6A6"/>
-          </a:solidFill>
-          <a:ln>
-            <a:noFill/>
-          </a:ln>
-        </p:spPr>
-        <p:style>
-          <a:lnRef idx="1">
-            <a:schemeClr val="accent1"/>
-          </a:lnRef>
-          <a:fillRef idx="3">
-            <a:schemeClr val="accent1"/>
-          </a:fillRef>
-          <a:effectRef idx="2">
-            <a:schemeClr val="accent1"/>
-          </a:effectRef>
-          <a:fontRef idx="minor">
-            <a:schemeClr val="lt1"/>
-          </a:fontRef>
-        </p:style>
-        <p:txBody>
-          <a:bodyPr rtlCol="0" anchor="ctr"/>
-          <a:lstStyle/>
-          <a:p>
-            <a:pPr algn="ctr"/>
-          </a:p>
-        </p:txBody>
-      </p:sp>
-      <p:sp>
-        <p:nvSpPr>
-          <p:cNvPr id="3" name="TextBox 2"/>
-          <p:cNvSpPr txBox="1"/>
-          <p:nvPr/>
-        </p:nvSpPr>
-        <p:spPr>
-          <a:xfrm>
-            <a:off x="594360" y="411480"/>
-            <a:ext cx="10972800" cy="640080"/>
-          </a:xfrm>
-          <a:prstGeom prst="rect">
-            <a:avLst/>
-          </a:prstGeom>
-          <a:noFill/>
-        </p:spPr>
-        <p:txBody>
-          <a:bodyPr wrap="none">
-            <a:spAutoFit/>
-          </a:bodyPr>
-          <a:lstStyle/>
-          <a:p>
-            <a:pPr>
-              <a:defRPr sz="2900" b="1">
-                <a:solidFill>
-                  <a:srgbClr val="062B3F"/>
-                </a:solidFill>
-                <a:latin typeface="Aptos Display"/>
-              </a:defRPr>
-            </a:pPr>
-            <a:r>
-              <a:t>Real-World Connection</a:t>
-            </a:r>
-          </a:p>
-        </p:txBody>
-      </p:sp>
-      <p:sp>
-        <p:nvSpPr>
-          <p:cNvPr id="4" name="TextBox 3"/>
-          <p:cNvSpPr txBox="1"/>
-          <p:nvPr/>
-        </p:nvSpPr>
-        <p:spPr>
-          <a:xfrm>
-            <a:off x="822960" y="1463040"/>
-            <a:ext cx="10561320" cy="4480560"/>
-          </a:xfrm>
-          <a:prstGeom prst="rect">
-            <a:avLst/>
-          </a:prstGeom>
-          <a:noFill/>
-        </p:spPr>
-        <p:txBody>
-          <a:bodyPr wrap="square">
-            <a:spAutoFit/>
-          </a:bodyPr>
-          <a:lstStyle/>
-          <a:p>
-            <a:pPr>
-              <a:spcAft>
-                <a:spcPts val="1400"/>
-              </a:spcAft>
-              <a:defRPr sz="2100">
-                <a:solidFill>
-                  <a:srgbClr val="1B262C"/>
-                </a:solidFill>
-                <a:latin typeface="Aptos"/>
-              </a:defRPr>
-            </a:pPr>
-            <a:r>
-              <a:t>Jennifer Miller</a:t>
-            </a:r>
-          </a:p>
-          <a:p>
-            <a:pPr>
-              <a:spcAft>
-                <a:spcPts val="1400"/>
-              </a:spcAft>
-              <a:defRPr sz="2100">
-                <a:solidFill>
-                  <a:srgbClr val="1B262C"/>
-                </a:solidFill>
-                <a:latin typeface="Aptos"/>
-              </a:defRPr>
-            </a:pPr>
-            <a:r>
-              <a:t>Ambassador Christian School</a:t>
-            </a:r>
-          </a:p>
-          <a:p>
-            <a:pPr>
-              <a:spcAft>
-                <a:spcPts val="1400"/>
-              </a:spcAft>
-              <a:defRPr sz="2100">
-                <a:solidFill>
-                  <a:srgbClr val="1B262C"/>
-                </a:solidFill>
-                <a:latin typeface="Aptos"/>
-              </a:defRPr>
-            </a:pPr>
-            <a:r>
-              <a:t>Professional self-presentation session</a:t>
-            </a:r>
-          </a:p>
-        </p:txBody>
-      </p:sp>
-      <p:sp>
-        <p:nvSpPr>
-          <p:cNvPr id="5" name="Rectangle 4"/>
-          <p:cNvSpPr/>
-          <p:nvPr/>
-        </p:nvSpPr>
-        <p:spPr>
-          <a:xfrm>
-            <a:off x="0" y="6446520"/>
-            <a:ext cx="12191695" cy="411480"/>
-          </a:xfrm>
-          <a:prstGeom prst="rect">
-            <a:avLst/>
-          </a:prstGeom>
-          <a:solidFill>
-            <a:srgbClr val="062B3F"/>
-          </a:solidFill>
-          <a:ln>
-            <a:noFill/>
-          </a:ln>
-        </p:spPr>
-        <p:style>
-          <a:lnRef idx="1">
-            <a:schemeClr val="accent1"/>
-          </a:lnRef>
-          <a:fillRef idx="3">
-            <a:schemeClr val="accent1"/>
-          </a:fillRef>
-          <a:effectRef idx="2">
-            <a:schemeClr val="accent1"/>
-          </a:effectRef>
-          <a:fontRef idx="minor">
-            <a:schemeClr val="lt1"/>
-          </a:fontRef>
-        </p:style>
-        <p:txBody>
-          <a:bodyPr rtlCol="0" anchor="ctr"/>
-          <a:lstStyle/>
-          <a:p>
-            <a:pPr algn="ctr"/>
-          </a:p>
-        </p:txBody>
-      </p:sp>
-      <p:sp>
-        <p:nvSpPr>
-          <p:cNvPr id="6" name="TextBox 5"/>
-          <p:cNvSpPr txBox="1"/>
-          <p:nvPr/>
-        </p:nvSpPr>
-        <p:spPr>
-          <a:xfrm>
-            <a:off x="457200" y="6510528"/>
-            <a:ext cx="11247120" cy="182880"/>
-          </a:xfrm>
-          <a:prstGeom prst="rect">
-            <a:avLst/>
-          </a:prstGeom>
-          <a:noFill/>
-        </p:spPr>
-        <p:txBody>
-          <a:bodyPr wrap="none">
-            <a:spAutoFit/>
-          </a:bodyPr>
-          <a:lstStyle/>
-          <a:p>
-            <a:pPr algn="ctr">
-              <a:defRPr sz="900">
-                <a:solidFill>
-                  <a:srgbClr val="FFFFFF"/>
-                </a:solidFill>
-              </a:defRPr>
-            </a:pPr>
-            <a:r>
-              <a:t>BUILD6™ · WEEK 9 · © 2026 LINK Lake Norman, LLC · All Rights Reserved</a:t>
-            </a:r>
-          </a:p>
-        </p:txBody>
-      </p:sp>
-    </p:spTree>
-  </p:cSld>
-  <p:clrMapOvr>
-    <a:masterClrMapping/>
-  </p:clrMapOvr>
-</p:sld>
-</file>
-
-<file path=ppt/slides/slide5.xml><?xml version="1.0" encoding="utf-8"?>
-<p:sld xmlns:a="http://schemas.openxmlformats.org/drawingml/2006/main" xmlns:p="http://schemas.openxmlformats.org/presentationml/2006/main" xmlns:r="http://schemas.openxmlformats.org/officeDocument/2006/relationships">
-  <p:cSld>
-    <p:bg>
-      <p:bgPr>
-        <a:solidFill>
-          <a:srgbClr val="F5F9FA"/>
-        </a:solidFill>
-        <a:effectLst/>
-      </p:bgPr>
-    </p:bg>
-    <p:spTree>
-      <p:nvGrpSpPr>
-        <p:cNvPr id="1" name=""/>
-        <p:cNvGrpSpPr/>
-        <p:nvPr/>
-      </p:nvGrpSpPr>
-      <p:grpSpPr/>
-      <p:sp>
-        <p:nvSpPr>
-          <p:cNvPr id="2" name="Rectangle 1"/>
-          <p:cNvSpPr/>
-          <p:nvPr/>
-        </p:nvSpPr>
-        <p:spPr>
-          <a:xfrm>
-            <a:off x="0" y="0"/>
-            <a:ext cx="164592" cy="6858000"/>
-          </a:xfrm>
-          <a:prstGeom prst="rect">
-            <a:avLst/>
-          </a:prstGeom>
-          <a:solidFill>
-            <a:srgbClr val="00A6A6"/>
-          </a:solidFill>
-          <a:ln>
-            <a:noFill/>
-          </a:ln>
-        </p:spPr>
-        <p:style>
-          <a:lnRef idx="1">
-            <a:schemeClr val="accent1"/>
-          </a:lnRef>
-          <a:fillRef idx="3">
-            <a:schemeClr val="accent1"/>
-          </a:fillRef>
-          <a:effectRef idx="2">
-            <a:schemeClr val="accent1"/>
-          </a:effectRef>
-          <a:fontRef idx="minor">
-            <a:schemeClr val="lt1"/>
-          </a:fontRef>
-        </p:style>
-        <p:txBody>
-          <a:bodyPr rtlCol="0" anchor="ctr"/>
-          <a:lstStyle/>
-          <a:p>
-            <a:pPr algn="ctr"/>
-          </a:p>
-        </p:txBody>
-      </p:sp>
-      <p:sp>
-        <p:nvSpPr>
-          <p:cNvPr id="3" name="TextBox 2"/>
-          <p:cNvSpPr txBox="1"/>
-          <p:nvPr/>
-        </p:nvSpPr>
-        <p:spPr>
-          <a:xfrm>
-            <a:off x="594360" y="411480"/>
-            <a:ext cx="10972800" cy="640080"/>
-          </a:xfrm>
-          <a:prstGeom prst="rect">
-            <a:avLst/>
-          </a:prstGeom>
-          <a:noFill/>
-        </p:spPr>
-        <p:txBody>
-          <a:bodyPr wrap="none">
-            <a:spAutoFit/>
-          </a:bodyPr>
-          <a:lstStyle/>
-          <a:p>
-            <a:pPr>
-              <a:defRPr sz="2900" b="1">
-                <a:solidFill>
-                  <a:srgbClr val="062B3F"/>
-                </a:solidFill>
-                <a:latin typeface="Aptos Display"/>
-              </a:defRPr>
-            </a:pPr>
-            <a:r>
-              <a:t>Before: Prepare With Purpose</a:t>
-            </a:r>
-          </a:p>
-        </p:txBody>
-      </p:sp>
-      <p:sp>
-        <p:nvSpPr>
-          <p:cNvPr id="4" name="TextBox 3"/>
-          <p:cNvSpPr txBox="1"/>
-          <p:nvPr/>
-        </p:nvSpPr>
-        <p:spPr>
-          <a:xfrm>
-            <a:off x="822960" y="1463040"/>
-            <a:ext cx="10561320" cy="4480560"/>
-          </a:xfrm>
-          <a:prstGeom prst="rect">
-            <a:avLst/>
-          </a:prstGeom>
-          <a:noFill/>
-        </p:spPr>
-        <p:txBody>
-          <a:bodyPr wrap="square">
-            <a:spAutoFit/>
-          </a:bodyPr>
-          <a:lstStyle/>
-          <a:p>
-            <a:pPr>
-              <a:spcAft>
-                <a:spcPts val="1400"/>
-              </a:spcAft>
-              <a:defRPr sz="2100">
-                <a:solidFill>
-                  <a:srgbClr val="1B262C"/>
-                </a:solidFill>
-                <a:latin typeface="Aptos"/>
-              </a:defRPr>
-            </a:pPr>
-            <a:r>
-              <a:t>What do I already know?</a:t>
-            </a:r>
-          </a:p>
-          <a:p>
-            <a:pPr>
-              <a:spcAft>
-                <a:spcPts val="1400"/>
-              </a:spcAft>
-              <a:defRPr sz="2100">
-                <a:solidFill>
-                  <a:srgbClr val="1B262C"/>
-                </a:solidFill>
-                <a:latin typeface="Aptos"/>
-              </a:defRPr>
-            </a:pPr>
-            <a:r>
-              <a:t>What assumptions am I bringing?</a:t>
-            </a:r>
-          </a:p>
-          <a:p>
-            <a:pPr>
-              <a:spcAft>
-                <a:spcPts val="1400"/>
-              </a:spcAft>
-              <a:defRPr sz="2100">
-                <a:solidFill>
-                  <a:srgbClr val="1B262C"/>
-                </a:solidFill>
-                <a:latin typeface="Aptos"/>
-              </a:defRPr>
-            </a:pPr>
-            <a:r>
-              <a:t>What should I pay attention to?</a:t>
-            </a:r>
-          </a:p>
-          <a:p>
-            <a:pPr>
-              <a:spcAft>
-                <a:spcPts val="1400"/>
-              </a:spcAft>
-              <a:defRPr sz="2100">
-                <a:solidFill>
-                  <a:srgbClr val="1B262C"/>
-                </a:solidFill>
-                <a:latin typeface="Aptos"/>
-              </a:defRPr>
-            </a:pPr>
-            <a:r>
-              <a:t>What question is worth asking?</a:t>
-            </a:r>
-          </a:p>
-        </p:txBody>
-      </p:sp>
-      <p:sp>
-        <p:nvSpPr>
-          <p:cNvPr id="5" name="Rectangle 4"/>
-          <p:cNvSpPr/>
-          <p:nvPr/>
-        </p:nvSpPr>
-        <p:spPr>
-          <a:xfrm>
-            <a:off x="0" y="6446520"/>
-            <a:ext cx="12191695" cy="411480"/>
-          </a:xfrm>
-          <a:prstGeom prst="rect">
-            <a:avLst/>
-          </a:prstGeom>
-          <a:solidFill>
-            <a:srgbClr val="062B3F"/>
-          </a:solidFill>
-          <a:ln>
-            <a:noFill/>
-          </a:ln>
-        </p:spPr>
-        <p:style>
-          <a:lnRef idx="1">
-            <a:schemeClr val="accent1"/>
-          </a:lnRef>
-          <a:fillRef idx="3">
-            <a:schemeClr val="accent1"/>
-          </a:fillRef>
-          <a:effectRef idx="2">
-            <a:schemeClr val="accent1"/>
-          </a:effectRef>
-          <a:fontRef idx="minor">
-            <a:schemeClr val="lt1"/>
-          </a:fontRef>
-        </p:style>
-        <p:txBody>
-          <a:bodyPr rtlCol="0" anchor="ctr"/>
-          <a:lstStyle/>
-          <a:p>
-            <a:pPr algn="ctr"/>
-          </a:p>
-        </p:txBody>
-      </p:sp>
-      <p:sp>
-        <p:nvSpPr>
-          <p:cNvPr id="6" name="TextBox 5"/>
-          <p:cNvSpPr txBox="1"/>
-          <p:nvPr/>
-        </p:nvSpPr>
-        <p:spPr>
-          <a:xfrm>
-            <a:off x="457200" y="6510528"/>
-            <a:ext cx="11247120" cy="182880"/>
-          </a:xfrm>
-          <a:prstGeom prst="rect">
-            <a:avLst/>
-          </a:prstGeom>
-          <a:noFill/>
-        </p:spPr>
-        <p:txBody>
-          <a:bodyPr wrap="none">
-            <a:spAutoFit/>
-          </a:bodyPr>
-          <a:lstStyle/>
-          <a:p>
-            <a:pPr algn="ctr">
-              <a:defRPr sz="900">
-                <a:solidFill>
-                  <a:srgbClr val="FFFFFF"/>
-                </a:solidFill>
-              </a:defRPr>
-            </a:pPr>
-            <a:r>
-              <a:t>BUILD6™ · WEEK 9 · © 2026 LINK Lake Norman, LLC · All Rights Reserved</a:t>
-            </a:r>
-          </a:p>
-        </p:txBody>
-      </p:sp>
-    </p:spTree>
-  </p:cSld>
-  <p:clrMapOvr>
-    <a:masterClrMapping/>
-  </p:clrMapOvr>
-</p:sld>
-</file>
-
-<file path=ppt/slides/slide6.xml><?xml version="1.0" encoding="utf-8"?>
-<p:sld xmlns:a="http://schemas.openxmlformats.org/drawingml/2006/main" xmlns:p="http://schemas.openxmlformats.org/presentationml/2006/main" xmlns:r="http://schemas.openxmlformats.org/officeDocument/2006/relationships">
-  <p:cSld>
-    <p:bg>
-      <p:bgPr>
-        <a:solidFill>
-          <a:srgbClr val="F5F9FA"/>
-        </a:solidFill>
-        <a:effectLst/>
-      </p:bgPr>
-    </p:bg>
-    <p:spTree>
-      <p:nvGrpSpPr>
-        <p:cNvPr id="1" name=""/>
-        <p:cNvGrpSpPr/>
-        <p:nvPr/>
-      </p:nvGrpSpPr>
-      <p:grpSpPr/>
-      <p:sp>
-        <p:nvSpPr>
-          <p:cNvPr id="2" name="Rectangle 1"/>
-          <p:cNvSpPr/>
-          <p:nvPr/>
-        </p:nvSpPr>
-        <p:spPr>
-          <a:xfrm>
-            <a:off x="0" y="0"/>
-            <a:ext cx="164592" cy="6858000"/>
-          </a:xfrm>
-          <a:prstGeom prst="rect">
-            <a:avLst/>
-          </a:prstGeom>
-          <a:solidFill>
-            <a:srgbClr val="00A6A6"/>
-          </a:solidFill>
-          <a:ln>
-            <a:noFill/>
-          </a:ln>
-        </p:spPr>
-        <p:style>
-          <a:lnRef idx="1">
-            <a:schemeClr val="accent1"/>
-          </a:lnRef>
-          <a:fillRef idx="3">
-            <a:schemeClr val="accent1"/>
-          </a:fillRef>
-          <a:effectRef idx="2">
-            <a:schemeClr val="accent1"/>
-          </a:effectRef>
-          <a:fontRef idx="minor">
-            <a:schemeClr val="lt1"/>
-          </a:fontRef>
-        </p:style>
-        <p:txBody>
-          <a:bodyPr rtlCol="0" anchor="ctr"/>
-          <a:lstStyle/>
-          <a:p>
-            <a:pPr algn="ctr"/>
-          </a:p>
-        </p:txBody>
-      </p:sp>
-      <p:sp>
-        <p:nvSpPr>
-          <p:cNvPr id="3" name="TextBox 2"/>
-          <p:cNvSpPr txBox="1"/>
-          <p:nvPr/>
-        </p:nvSpPr>
-        <p:spPr>
-          <a:xfrm>
-            <a:off x="594360" y="411480"/>
-            <a:ext cx="10972800" cy="640080"/>
-          </a:xfrm>
-          <a:prstGeom prst="rect">
-            <a:avLst/>
-          </a:prstGeom>
-          <a:noFill/>
-        </p:spPr>
-        <p:txBody>
-          <a:bodyPr wrap="none">
-            <a:spAutoFit/>
-          </a:bodyPr>
-          <a:lstStyle/>
-          <a:p>
-            <a:pPr>
-              <a:defRPr sz="2900" b="1">
-                <a:solidFill>
-                  <a:srgbClr val="062B3F"/>
-                </a:solidFill>
-                <a:latin typeface="Aptos Display"/>
-              </a:defRPr>
-            </a:pPr>
-            <a:r>
-              <a:t>Activity / Challenge</a:t>
-            </a:r>
-          </a:p>
-        </p:txBody>
-      </p:sp>
-      <p:sp>
-        <p:nvSpPr>
-          <p:cNvPr id="4" name="TextBox 3"/>
-          <p:cNvSpPr txBox="1"/>
-          <p:nvPr/>
-        </p:nvSpPr>
-        <p:spPr>
-          <a:xfrm>
-            <a:off x="822960" y="1463040"/>
-            <a:ext cx="10561320" cy="4480560"/>
-          </a:xfrm>
-          <a:prstGeom prst="rect">
-            <a:avLst/>
-          </a:prstGeom>
-          <a:noFill/>
-        </p:spPr>
-        <p:txBody>
-          <a:bodyPr wrap="square">
-            <a:spAutoFit/>
-          </a:bodyPr>
-          <a:lstStyle/>
-          <a:p>
-            <a:pPr>
-              <a:spcAft>
-                <a:spcPts val="1400"/>
-              </a:spcAft>
-              <a:defRPr sz="2100">
-                <a:solidFill>
-                  <a:srgbClr val="1B262C"/>
-                </a:solidFill>
-                <a:latin typeface="Aptos"/>
-              </a:defRPr>
-            </a:pPr>
-            <a:r>
-              <a:t>Convert one athletic experience into a workplace story.</a:t>
-            </a:r>
-          </a:p>
-          <a:p>
-            <a:pPr>
-              <a:spcAft>
-                <a:spcPts val="1400"/>
-              </a:spcAft>
-              <a:defRPr sz="2100">
-                <a:solidFill>
-                  <a:srgbClr val="1B262C"/>
-                </a:solidFill>
-                <a:latin typeface="Aptos"/>
-              </a:defRPr>
-            </a:pPr>
-            <a:r>
-              <a:t>Identify situation, action and result.</a:t>
-            </a:r>
-          </a:p>
-          <a:p>
-            <a:pPr>
-              <a:spcAft>
-                <a:spcPts val="1400"/>
-              </a:spcAft>
-              <a:defRPr sz="2100">
-                <a:solidFill>
-                  <a:srgbClr val="1B262C"/>
-                </a:solidFill>
-                <a:latin typeface="Aptos"/>
-              </a:defRPr>
-            </a:pPr>
-            <a:r>
-              <a:t>Practice telling the story without overselling it.</a:t>
-            </a:r>
-          </a:p>
-        </p:txBody>
-      </p:sp>
-      <p:sp>
-        <p:nvSpPr>
-          <p:cNvPr id="5" name="Rectangle 4"/>
-          <p:cNvSpPr/>
-          <p:nvPr/>
-        </p:nvSpPr>
-        <p:spPr>
-          <a:xfrm>
-            <a:off x="0" y="6446520"/>
-            <a:ext cx="12191695" cy="411480"/>
-          </a:xfrm>
-          <a:prstGeom prst="rect">
-            <a:avLst/>
-          </a:prstGeom>
-          <a:solidFill>
-            <a:srgbClr val="062B3F"/>
-          </a:solidFill>
-          <a:ln>
-            <a:noFill/>
-          </a:ln>
-        </p:spPr>
-        <p:style>
-          <a:lnRef idx="1">
-            <a:schemeClr val="accent1"/>
-          </a:lnRef>
-          <a:fillRef idx="3">
-            <a:schemeClr val="accent1"/>
-          </a:fillRef>
-          <a:effectRef idx="2">
-            <a:schemeClr val="accent1"/>
-          </a:effectRef>
-          <a:fontRef idx="minor">
-            <a:schemeClr val="lt1"/>
-          </a:fontRef>
-        </p:style>
-        <p:txBody>
-          <a:bodyPr rtlCol="0" anchor="ctr"/>
-          <a:lstStyle/>
-          <a:p>
-            <a:pPr algn="ctr"/>
-          </a:p>
-        </p:txBody>
-      </p:sp>
-      <p:sp>
-        <p:nvSpPr>
-          <p:cNvPr id="6" name="TextBox 5"/>
-          <p:cNvSpPr txBox="1"/>
-          <p:nvPr/>
-        </p:nvSpPr>
-        <p:spPr>
-          <a:xfrm>
-            <a:off x="457200" y="6510528"/>
-            <a:ext cx="11247120" cy="182880"/>
-          </a:xfrm>
-          <a:prstGeom prst="rect">
-            <a:avLst/>
-          </a:prstGeom>
-          <a:noFill/>
-        </p:spPr>
-        <p:txBody>
-          <a:bodyPr wrap="none">
-            <a:spAutoFit/>
-          </a:bodyPr>
-          <a:lstStyle/>
-          <a:p>
-            <a:pPr algn="ctr">
-              <a:defRPr sz="900">
-                <a:solidFill>
-                  <a:srgbClr val="FFFFFF"/>
-                </a:solidFill>
-              </a:defRPr>
-            </a:pPr>
-            <a:r>
-              <a:t>BUILD6™ · WEEK 9 · © 2026 LINK Lake Norman, LLC · All Rights Reserved</a:t>
-            </a:r>
-          </a:p>
-        </p:txBody>
-      </p:sp>
-    </p:spTree>
-  </p:cSld>
-  <p:clrMapOvr>
-    <a:masterClrMapping/>
-  </p:clrMapOvr>
-</p:sld>
-</file>
-
-<file path=ppt/slides/slide7.xml><?xml version="1.0" encoding="utf-8"?>
-<p:sld xmlns:a="http://schemas.openxmlformats.org/drawingml/2006/main" xmlns:p="http://schemas.openxmlformats.org/presentationml/2006/main" xmlns:r="http://schemas.openxmlformats.org/officeDocument/2006/relationships">
-  <p:cSld>
-    <p:bg>
-      <p:bgPr>
-        <a:solidFill>
-          <a:srgbClr val="F5F9FA"/>
-        </a:solidFill>
-        <a:effectLst/>
-      </p:bgPr>
-    </p:bg>
-    <p:spTree>
-      <p:nvGrpSpPr>
-        <p:cNvPr id="1" name=""/>
-        <p:cNvGrpSpPr/>
-        <p:nvPr/>
-      </p:nvGrpSpPr>
-      <p:grpSpPr/>
-      <p:sp>
-        <p:nvSpPr>
-          <p:cNvPr id="2" name="Rectangle 1"/>
-          <p:cNvSpPr/>
-          <p:nvPr/>
-        </p:nvSpPr>
-        <p:spPr>
-          <a:xfrm>
-            <a:off x="0" y="0"/>
-            <a:ext cx="164592" cy="6858000"/>
-          </a:xfrm>
-          <a:prstGeom prst="rect">
-            <a:avLst/>
-          </a:prstGeom>
-          <a:solidFill>
-            <a:srgbClr val="00A6A6"/>
-          </a:solidFill>
-          <a:ln>
-            <a:noFill/>
-          </a:ln>
-        </p:spPr>
-        <p:style>
-          <a:lnRef idx="1">
-            <a:schemeClr val="accent1"/>
-          </a:lnRef>
-          <a:fillRef idx="3">
-            <a:schemeClr val="accent1"/>
-          </a:fillRef>
-          <a:effectRef idx="2">
-            <a:schemeClr val="accent1"/>
-          </a:effectRef>
-          <a:fontRef idx="minor">
-            <a:schemeClr val="lt1"/>
-          </a:fontRef>
-        </p:style>
-        <p:txBody>
-          <a:bodyPr rtlCol="0" anchor="ctr"/>
-          <a:lstStyle/>
-          <a:p>
-            <a:pPr algn="ctr"/>
-          </a:p>
-        </p:txBody>
-      </p:sp>
-      <p:sp>
-        <p:nvSpPr>
-          <p:cNvPr id="3" name="TextBox 2"/>
-          <p:cNvSpPr txBox="1"/>
-          <p:nvPr/>
-        </p:nvSpPr>
-        <p:spPr>
-          <a:xfrm>
-            <a:off x="594360" y="411480"/>
-            <a:ext cx="10972800" cy="640080"/>
-          </a:xfrm>
-          <a:prstGeom prst="rect">
-            <a:avLst/>
-          </a:prstGeom>
-          <a:noFill/>
-        </p:spPr>
-        <p:txBody>
-          <a:bodyPr wrap="none">
-            <a:spAutoFit/>
-          </a:bodyPr>
-          <a:lstStyle/>
-          <a:p>
-            <a:pPr>
-              <a:defRPr sz="2900" b="1">
-                <a:solidFill>
-                  <a:srgbClr val="062B3F"/>
-                </a:solidFill>
-                <a:latin typeface="Aptos Display"/>
-              </a:defRPr>
-            </a:pPr>
-            <a:r>
-              <a:t>Professional Questions</a:t>
-            </a:r>
-          </a:p>
-        </p:txBody>
-      </p:sp>
-      <p:sp>
-        <p:nvSpPr>
-          <p:cNvPr id="4" name="TextBox 3"/>
-          <p:cNvSpPr txBox="1"/>
-          <p:nvPr/>
-        </p:nvSpPr>
-        <p:spPr>
-          <a:xfrm>
-            <a:off x="822960" y="1463040"/>
-            <a:ext cx="10561320" cy="4480560"/>
-          </a:xfrm>
-          <a:prstGeom prst="rect">
-            <a:avLst/>
-          </a:prstGeom>
-          <a:noFill/>
-        </p:spPr>
-        <p:txBody>
-          <a:bodyPr wrap="square">
-            <a:spAutoFit/>
-          </a:bodyPr>
-          <a:lstStyle/>
-          <a:p>
-            <a:pPr>
-              <a:spcAft>
-                <a:spcPts val="1400"/>
-              </a:spcAft>
-              <a:defRPr sz="2100">
-                <a:solidFill>
-                  <a:srgbClr val="1B262C"/>
-                </a:solidFill>
-                <a:latin typeface="Aptos"/>
-              </a:defRPr>
-            </a:pPr>
-            <a:r>
-              <a:t>What makes an experience resume-worthy?</a:t>
-            </a:r>
-          </a:p>
-          <a:p>
-            <a:pPr>
-              <a:spcAft>
-                <a:spcPts val="1400"/>
-              </a:spcAft>
-              <a:defRPr sz="2100">
-                <a:solidFill>
-                  <a:srgbClr val="1B262C"/>
-                </a:solidFill>
-                <a:latin typeface="Aptos"/>
-              </a:defRPr>
-            </a:pPr>
-            <a:r>
-              <a:t>How do I show a skill instead of merely naming it?</a:t>
-            </a:r>
-          </a:p>
-          <a:p>
-            <a:pPr>
-              <a:spcAft>
-                <a:spcPts val="1400"/>
-              </a:spcAft>
-              <a:defRPr sz="2100">
-                <a:solidFill>
-                  <a:srgbClr val="1B262C"/>
-                </a:solidFill>
-                <a:latin typeface="Aptos"/>
-              </a:defRPr>
-            </a:pPr>
-            <a:r>
-              <a:t>What story best demonstrates how I work with others?</a:t>
-            </a:r>
-          </a:p>
-        </p:txBody>
-      </p:sp>
-      <p:sp>
-        <p:nvSpPr>
-          <p:cNvPr id="5" name="Rectangle 4"/>
-          <p:cNvSpPr/>
-          <p:nvPr/>
-        </p:nvSpPr>
-        <p:spPr>
-          <a:xfrm>
-            <a:off x="0" y="6446520"/>
-            <a:ext cx="12191695" cy="411480"/>
-          </a:xfrm>
-          <a:prstGeom prst="rect">
-            <a:avLst/>
-          </a:prstGeom>
-          <a:solidFill>
-            <a:srgbClr val="062B3F"/>
-          </a:solidFill>
-          <a:ln>
-            <a:noFill/>
-          </a:ln>
-        </p:spPr>
-        <p:style>
-          <a:lnRef idx="1">
-            <a:schemeClr val="accent1"/>
-          </a:lnRef>
-          <a:fillRef idx="3">
-            <a:schemeClr val="accent1"/>
-          </a:fillRef>
-          <a:effectRef idx="2">
-            <a:schemeClr val="accent1"/>
-          </a:effectRef>
-          <a:fontRef idx="minor">
-            <a:schemeClr val="lt1"/>
-          </a:fontRef>
-        </p:style>
-        <p:txBody>
-          <a:bodyPr rtlCol="0" anchor="ctr"/>
-          <a:lstStyle/>
-          <a:p>
-            <a:pPr algn="ctr"/>
-          </a:p>
-        </p:txBody>
-      </p:sp>
-      <p:sp>
-        <p:nvSpPr>
-          <p:cNvPr id="6" name="TextBox 5"/>
-          <p:cNvSpPr txBox="1"/>
-          <p:nvPr/>
-        </p:nvSpPr>
-        <p:spPr>
-          <a:xfrm>
-            <a:off x="457200" y="6510528"/>
-            <a:ext cx="11247120" cy="182880"/>
-          </a:xfrm>
-          <a:prstGeom prst="rect">
-            <a:avLst/>
-          </a:prstGeom>
-          <a:noFill/>
-        </p:spPr>
-        <p:txBody>
-          <a:bodyPr wrap="none">
-            <a:spAutoFit/>
-          </a:bodyPr>
-          <a:lstStyle/>
-          <a:p>
-            <a:pPr algn="ctr">
-              <a:defRPr sz="900">
-                <a:solidFill>
-                  <a:srgbClr val="FFFFFF"/>
-                </a:solidFill>
-              </a:defRPr>
-            </a:pPr>
-            <a:r>
-              <a:t>BUILD6™ · WEEK 9 · © 2026 LINK Lake Norman, LLC · All Rights Reserved</a:t>
-            </a:r>
-          </a:p>
-        </p:txBody>
-      </p:sp>
-    </p:spTree>
-  </p:cSld>
-  <p:clrMapOvr>
-    <a:masterClrMapping/>
-  </p:clrMapOvr>
-</p:sld>
-</file>
-
-<file path=ppt/slides/slide8.xml><?xml version="1.0" encoding="utf-8"?>
-<p:sld xmlns:a="http://schemas.openxmlformats.org/drawingml/2006/main" xmlns:p="http://schemas.openxmlformats.org/presentationml/2006/main" xmlns:r="http://schemas.openxmlformats.org/officeDocument/2006/relationships">
-  <p:cSld>
-    <p:bg>
-      <p:bgPr>
-        <a:solidFill>
-          <a:srgbClr val="F5F9FA"/>
-        </a:solidFill>
-        <a:effectLst/>
-      </p:bgPr>
-    </p:bg>
-    <p:spTree>
-      <p:nvGrpSpPr>
-        <p:cNvPr id="1" name=""/>
-        <p:cNvGrpSpPr/>
-        <p:nvPr/>
-      </p:nvGrpSpPr>
-      <p:grpSpPr/>
-      <p:sp>
-        <p:nvSpPr>
-          <p:cNvPr id="2" name="Rectangle 1"/>
-          <p:cNvSpPr/>
-          <p:nvPr/>
-        </p:nvSpPr>
-        <p:spPr>
-          <a:xfrm>
-            <a:off x="0" y="0"/>
-            <a:ext cx="164592" cy="6858000"/>
-          </a:xfrm>
-          <a:prstGeom prst="rect">
-            <a:avLst/>
-          </a:prstGeom>
-          <a:solidFill>
-            <a:srgbClr val="00A6A6"/>
-          </a:solidFill>
-          <a:ln>
-            <a:noFill/>
-          </a:ln>
-        </p:spPr>
-        <p:style>
-          <a:lnRef idx="1">
-            <a:schemeClr val="accent1"/>
-          </a:lnRef>
-          <a:fillRef idx="3">
-            <a:schemeClr val="accent1"/>
-          </a:fillRef>
-          <a:effectRef idx="2">
-            <a:schemeClr val="accent1"/>
-          </a:effectRef>
-          <a:fontRef idx="minor">
-            <a:schemeClr val="lt1"/>
-          </a:fontRef>
-        </p:style>
-        <p:txBody>
-          <a:bodyPr rtlCol="0" anchor="ctr"/>
-          <a:lstStyle/>
-          <a:p>
-            <a:pPr algn="ctr"/>
-          </a:p>
-        </p:txBody>
-      </p:sp>
-      <p:sp>
-        <p:nvSpPr>
-          <p:cNvPr id="3" name="TextBox 2"/>
-          <p:cNvSpPr txBox="1"/>
-          <p:nvPr/>
-        </p:nvSpPr>
-        <p:spPr>
-          <a:xfrm>
-            <a:off x="594360" y="411480"/>
-            <a:ext cx="10972800" cy="640080"/>
-          </a:xfrm>
-          <a:prstGeom prst="rect">
-            <a:avLst/>
-          </a:prstGeom>
-          <a:noFill/>
-        </p:spPr>
-        <p:txBody>
-          <a:bodyPr wrap="none">
-            <a:spAutoFit/>
-          </a:bodyPr>
-          <a:lstStyle/>
-          <a:p>
-            <a:pPr>
-              <a:defRPr sz="2900" b="1">
-                <a:solidFill>
-                  <a:srgbClr val="062B3F"/>
-                </a:solidFill>
-                <a:latin typeface="Aptos Display"/>
-              </a:defRPr>
-            </a:pPr>
-            <a:r>
-              <a:t>During: Capture Evidence</a:t>
-            </a:r>
-          </a:p>
-        </p:txBody>
-      </p:sp>
-      <p:sp>
-        <p:nvSpPr>
-          <p:cNvPr id="4" name="TextBox 3"/>
-          <p:cNvSpPr txBox="1"/>
-          <p:nvPr/>
-        </p:nvSpPr>
-        <p:spPr>
-          <a:xfrm>
-            <a:off x="822960" y="1463040"/>
-            <a:ext cx="10561320" cy="4480560"/>
-          </a:xfrm>
-          <a:prstGeom prst="rect">
-            <a:avLst/>
-          </a:prstGeom>
-          <a:noFill/>
-        </p:spPr>
-        <p:txBody>
-          <a:bodyPr wrap="square">
-            <a:spAutoFit/>
-          </a:bodyPr>
-          <a:lstStyle/>
-          <a:p>
-            <a:pPr>
-              <a:spcAft>
-                <a:spcPts val="1400"/>
-              </a:spcAft>
-              <a:defRPr sz="2100">
-                <a:solidFill>
-                  <a:srgbClr val="1B262C"/>
-                </a:solidFill>
-                <a:latin typeface="Aptos"/>
-              </a:defRPr>
-            </a:pPr>
-            <a:r>
-              <a:t>Write down something specific—not merely 'it was interesting.'</a:t>
-            </a:r>
-          </a:p>
-          <a:p>
-            <a:pPr>
-              <a:spcAft>
-                <a:spcPts val="1400"/>
-              </a:spcAft>
-              <a:defRPr sz="2100">
-                <a:solidFill>
-                  <a:srgbClr val="1B262C"/>
-                </a:solidFill>
-                <a:latin typeface="Aptos"/>
-              </a:defRPr>
-            </a:pPr>
-            <a:r>
-              <a:t>Notice a skill in action.</a:t>
-            </a:r>
-          </a:p>
-          <a:p>
-            <a:pPr>
-              <a:spcAft>
-                <a:spcPts val="1400"/>
-              </a:spcAft>
-              <a:defRPr sz="2100">
-                <a:solidFill>
-                  <a:srgbClr val="1B262C"/>
-                </a:solidFill>
-                <a:latin typeface="Aptos"/>
-              </a:defRPr>
-            </a:pPr>
-            <a:r>
-              <a:t>Capture a quote, observation, decision or moment.</a:t>
-            </a:r>
-          </a:p>
-          <a:p>
-            <a:pPr>
-              <a:spcAft>
-                <a:spcPts val="1400"/>
-              </a:spcAft>
-              <a:defRPr sz="2100">
-                <a:solidFill>
-                  <a:srgbClr val="1B262C"/>
-                </a:solidFill>
-                <a:latin typeface="Aptos"/>
-              </a:defRPr>
-            </a:pPr>
-            <a:r>
-              <a:t>Identify evidence that could belong in your portfolio.</a:t>
-            </a:r>
-          </a:p>
-        </p:txBody>
-      </p:sp>
-      <p:sp>
-        <p:nvSpPr>
-          <p:cNvPr id="5" name="Rectangle 4"/>
-          <p:cNvSpPr/>
-          <p:nvPr/>
-        </p:nvSpPr>
-        <p:spPr>
-          <a:xfrm>
-            <a:off x="0" y="6446520"/>
-            <a:ext cx="12191695" cy="411480"/>
-          </a:xfrm>
-          <a:prstGeom prst="rect">
-            <a:avLst/>
-          </a:prstGeom>
-          <a:solidFill>
-            <a:srgbClr val="062B3F"/>
-          </a:solidFill>
-          <a:ln>
-            <a:noFill/>
-          </a:ln>
-        </p:spPr>
-        <p:style>
-          <a:lnRef idx="1">
-            <a:schemeClr val="accent1"/>
-          </a:lnRef>
-          <a:fillRef idx="3">
-            <a:schemeClr val="accent1"/>
-          </a:fillRef>
-          <a:effectRef idx="2">
-            <a:schemeClr val="accent1"/>
-          </a:effectRef>
-          <a:fontRef idx="minor">
-            <a:schemeClr val="lt1"/>
-          </a:fontRef>
-        </p:style>
-        <p:txBody>
-          <a:bodyPr rtlCol="0" anchor="ctr"/>
-          <a:lstStyle/>
-          <a:p>
-            <a:pPr algn="ctr"/>
-          </a:p>
-        </p:txBody>
-      </p:sp>
-      <p:sp>
-        <p:nvSpPr>
-          <p:cNvPr id="6" name="TextBox 5"/>
-          <p:cNvSpPr txBox="1"/>
-          <p:nvPr/>
-        </p:nvSpPr>
-        <p:spPr>
-          <a:xfrm>
-            <a:off x="457200" y="6510528"/>
-            <a:ext cx="11247120" cy="182880"/>
-          </a:xfrm>
-          <a:prstGeom prst="rect">
-            <a:avLst/>
-          </a:prstGeom>
-          <a:noFill/>
-        </p:spPr>
-        <p:txBody>
-          <a:bodyPr wrap="none">
-            <a:spAutoFit/>
-          </a:bodyPr>
-          <a:lstStyle/>
-          <a:p>
-            <a:pPr algn="ctr">
-              <a:defRPr sz="900">
-                <a:solidFill>
-                  <a:srgbClr val="FFFFFF"/>
-                </a:solidFill>
-              </a:defRPr>
-            </a:pPr>
-            <a:r>
-              <a:t>BUILD6™ · WEEK 9 · © 2026 LINK Lake Norman, LLC · All Rights Reserved</a:t>
-            </a:r>
-          </a:p>
-        </p:txBody>
-      </p:sp>
-    </p:spTree>
-  </p:cSld>
-  <p:clrMapOvr>
-    <a:masterClrMapping/>
-  </p:clrMapOvr>
-</p:sld>
-</file>
-
-<file path=ppt/slides/slide9.xml><?xml version="1.0" encoding="utf-8"?>
-<p:sld xmlns:a="http://schemas.openxmlformats.org/drawingml/2006/main" xmlns:p="http://schemas.openxmlformats.org/presentationml/2006/main" xmlns:r="http://schemas.openxmlformats.org/officeDocument/2006/relationships">
-  <p:cSld>
-    <p:bg>
-      <p:bgPr>
-        <a:solidFill>
-          <a:srgbClr val="F5F9FA"/>
-        </a:solidFill>
-        <a:effectLst/>
-      </p:bgPr>
-    </p:bg>
-    <p:spTree>
-      <p:nvGrpSpPr>
-        <p:cNvPr id="1" name=""/>
-        <p:cNvGrpSpPr/>
-        <p:nvPr/>
-      </p:nvGrpSpPr>
-      <p:grpSpPr/>
-      <p:sp>
-        <p:nvSpPr>
-          <p:cNvPr id="2" name="Rectangle 1"/>
-          <p:cNvSpPr/>
-          <p:nvPr/>
-        </p:nvSpPr>
-        <p:spPr>
-          <a:xfrm>
-            <a:off x="0" y="0"/>
-            <a:ext cx="164592" cy="6858000"/>
-          </a:xfrm>
-          <a:prstGeom prst="rect">
-            <a:avLst/>
-          </a:prstGeom>
-          <a:solidFill>
-            <a:srgbClr val="00A6A6"/>
-          </a:solidFill>
-          <a:ln>
-            <a:noFill/>
-          </a:ln>
-        </p:spPr>
-        <p:style>
-          <a:lnRef idx="1">
-            <a:schemeClr val="accent1"/>
-          </a:lnRef>
-          <a:fillRef idx="3">
-            <a:schemeClr val="accent1"/>
-          </a:fillRef>
-          <a:effectRef idx="2">
-            <a:schemeClr val="accent1"/>
-          </a:effectRef>
-          <a:fontRef idx="minor">
-            <a:schemeClr val="lt1"/>
-          </a:fontRef>
-        </p:style>
-        <p:txBody>
-          <a:bodyPr rtlCol="0" anchor="ctr"/>
-          <a:lstStyle/>
-          <a:p>
-            <a:pPr algn="ctr"/>
-          </a:p>
-        </p:txBody>
-      </p:sp>
-      <p:sp>
-        <p:nvSpPr>
-          <p:cNvPr id="3" name="TextBox 2"/>
-          <p:cNvSpPr txBox="1"/>
-          <p:nvPr/>
-        </p:nvSpPr>
-        <p:spPr>
-          <a:xfrm>
-            <a:off x="594360" y="411480"/>
-            <a:ext cx="10972800" cy="640080"/>
-          </a:xfrm>
-          <a:prstGeom prst="rect">
-            <a:avLst/>
-          </a:prstGeom>
-          <a:noFill/>
-        </p:spPr>
-        <p:txBody>
-          <a:bodyPr wrap="none">
-            <a:spAutoFit/>
-          </a:bodyPr>
-          <a:lstStyle/>
-          <a:p>
-            <a:pPr>
-              <a:defRPr sz="2900" b="1">
-                <a:solidFill>
-                  <a:srgbClr val="062B3F"/>
-                </a:solidFill>
-                <a:latin typeface="Aptos Display"/>
-              </a:defRPr>
-            </a:pPr>
-            <a:r>
-              <a:t>After: Reflection</a:t>
-            </a:r>
-          </a:p>
-        </p:txBody>
-      </p:sp>
-      <p:sp>
-        <p:nvSpPr>
-          <p:cNvPr id="4" name="TextBox 3"/>
-          <p:cNvSpPr txBox="1"/>
-          <p:nvPr/>
-        </p:nvSpPr>
-        <p:spPr>
-          <a:xfrm>
-            <a:off x="822960" y="1463040"/>
-            <a:ext cx="10561320" cy="4480560"/>
-          </a:xfrm>
-          <a:prstGeom prst="rect">
-            <a:avLst/>
-          </a:prstGeom>
-          <a:noFill/>
-        </p:spPr>
-        <p:txBody>
-          <a:bodyPr wrap="square">
-            <a:spAutoFit/>
-          </a:bodyPr>
-          <a:lstStyle/>
-          <a:p>
-            <a:pPr>
-              <a:spcAft>
-                <a:spcPts val="1400"/>
-              </a:spcAft>
-              <a:defRPr sz="2100">
-                <a:solidFill>
-                  <a:srgbClr val="1B262C"/>
-                </a:solidFill>
-                <a:latin typeface="Aptos"/>
-              </a:defRPr>
-            </a:pPr>
-            <a:r>
-              <a:t>Which story represents me accurately?</a:t>
-            </a:r>
-          </a:p>
-          <a:p>
-            <a:pPr>
-              <a:spcAft>
-                <a:spcPts val="1400"/>
-              </a:spcAft>
-              <a:defRPr sz="2100">
-                <a:solidFill>
-                  <a:srgbClr val="1B262C"/>
-                </a:solidFill>
-                <a:latin typeface="Aptos"/>
-              </a:defRPr>
-            </a:pPr>
-            <a:r>
-              <a:t>Where am I underselling myself?</a:t>
-            </a:r>
-          </a:p>
-          <a:p>
-            <a:pPr>
-              <a:spcAft>
-                <a:spcPts val="1400"/>
-              </a:spcAft>
-              <a:defRPr sz="2100">
-                <a:solidFill>
-                  <a:srgbClr val="1B262C"/>
-                </a:solidFill>
-                <a:latin typeface="Aptos"/>
-              </a:defRPr>
-            </a:pPr>
-            <a:r>
-              <a:t>What evidence still needs to be developed?</a:t>
-            </a:r>
-          </a:p>
-        </p:txBody>
-      </p:sp>
-      <p:sp>
-        <p:nvSpPr>
-          <p:cNvPr id="5" name="Rectangle 4"/>
-          <p:cNvSpPr/>
-          <p:nvPr/>
-        </p:nvSpPr>
-        <p:spPr>
-          <a:xfrm>
-            <a:off x="0" y="6446520"/>
-            <a:ext cx="12191695" cy="411480"/>
-          </a:xfrm>
-          <a:prstGeom prst="rect">
-            <a:avLst/>
-          </a:prstGeom>
-          <a:solidFill>
-            <a:srgbClr val="062B3F"/>
-          </a:solidFill>
-          <a:ln>
-            <a:noFill/>
-          </a:ln>
-        </p:spPr>
-        <p:style>
-          <a:lnRef idx="1">
-            <a:schemeClr val="accent1"/>
-          </a:lnRef>
-          <a:fillRef idx="3">
-            <a:schemeClr val="accent1"/>
-          </a:fillRef>
-          <a:effectRef idx="2">
-            <a:schemeClr val="accent1"/>
-          </a:effectRef>
-          <a:fontRef idx="minor">
-            <a:schemeClr val="lt1"/>
-          </a:fontRef>
-        </p:style>
-        <p:txBody>
-          <a:bodyPr rtlCol="0" anchor="ctr"/>
-          <a:lstStyle/>
-          <a:p>
-            <a:pPr algn="ctr"/>
-          </a:p>
-        </p:txBody>
-      </p:sp>
-      <p:sp>
-        <p:nvSpPr>
-          <p:cNvPr id="6" name="TextBox 5"/>
-          <p:cNvSpPr txBox="1"/>
-          <p:nvPr/>
-        </p:nvSpPr>
-        <p:spPr>
-          <a:xfrm>
-            <a:off x="457200" y="6510528"/>
-            <a:ext cx="11247120" cy="182880"/>
-          </a:xfrm>
-          <a:prstGeom prst="rect">
-            <a:avLst/>
-          </a:prstGeom>
-          <a:noFill/>
-        </p:spPr>
-        <p:txBody>
-          <a:bodyPr wrap="none">
-            <a:spAutoFit/>
-          </a:bodyPr>
-          <a:lstStyle/>
-          <a:p>
-            <a:pPr algn="ctr">
-              <a:defRPr sz="900">
-                <a:solidFill>
-                  <a:srgbClr val="FFFFFF"/>
-                </a:solidFill>
-              </a:defRPr>
-            </a:pPr>
-            <a:r>
-              <a:t>BUILD6™ · WEEK 9 · © 2026 LINK Lake Norman, LLC · All Rights Reserved</a:t>
+              <a:t>Capstone connection: Preserve one example showing how you used judgment: the original AI output, what you changed or rejected, what you verified, and why your final decision was better.</a:t>
             </a:r>
           </a:p>
         </p:txBody>

</xml_diff>